<commit_message>
D: refresh presentation with live sharing screenshots
</commit_message>
<xml_diff>
--- a/output/presentations/Smart_Notes_Project_Shared_Notes_v2.pptx
+++ b/output/presentations/Smart_Notes_Project_Shared_Notes_v2.pptx
@@ -2,19 +2,19 @@
 <file path=ppt/presentation.xml><?xml version="1.0" encoding="utf-8"?>
 <p:presentation xmlns:p="http://schemas.openxmlformats.org/presentationml/2006/main">
   <p:sldMasterIdLst>
-    <p:sldMasterId xmlns:r="http://schemas.openxmlformats.org/officeDocument/2006/relationships" id="2147483648" r:id="Rafd5e8565cd44c44"/>
+    <p:sldMasterId xmlns:r="http://schemas.openxmlformats.org/officeDocument/2006/relationships" id="2147483648" r:id="R37306470dcf84f55"/>
   </p:sldMasterIdLst>
   <p:notesMasterIdLst>
-    <p:notesMasterId xmlns:r="http://schemas.openxmlformats.org/officeDocument/2006/relationships" r:id="Rc67a342f31b84a40"/>
+    <p:notesMasterId xmlns:r="http://schemas.openxmlformats.org/officeDocument/2006/relationships" r:id="R1f87af0da09b4ecc"/>
   </p:notesMasterIdLst>
   <p:sldIdLst>
-    <p:sldId xmlns:r="http://schemas.openxmlformats.org/officeDocument/2006/relationships" id="256" r:id="Rb1389b9658a8497f"/>
-    <p:sldId xmlns:r="http://schemas.openxmlformats.org/officeDocument/2006/relationships" id="257" r:id="R082c004de5194981"/>
-    <p:sldId xmlns:r="http://schemas.openxmlformats.org/officeDocument/2006/relationships" id="258" r:id="R7c8627aa74d44d62"/>
-    <p:sldId xmlns:r="http://schemas.openxmlformats.org/officeDocument/2006/relationships" id="259" r:id="R079b3573f2694353"/>
-    <p:sldId xmlns:r="http://schemas.openxmlformats.org/officeDocument/2006/relationships" id="260" r:id="R46044f83095d475a"/>
-    <p:sldId xmlns:r="http://schemas.openxmlformats.org/officeDocument/2006/relationships" id="261" r:id="R075b8834ba814800"/>
-    <p:sldId xmlns:r="http://schemas.openxmlformats.org/officeDocument/2006/relationships" id="262" r:id="R29b38189a5464c0b"/>
+    <p:sldId xmlns:r="http://schemas.openxmlformats.org/officeDocument/2006/relationships" id="256" r:id="R1cab7c9024794e05"/>
+    <p:sldId xmlns:r="http://schemas.openxmlformats.org/officeDocument/2006/relationships" id="257" r:id="R94c77c7f698248f3"/>
+    <p:sldId xmlns:r="http://schemas.openxmlformats.org/officeDocument/2006/relationships" id="258" r:id="R6c6a54a59b674f7e"/>
+    <p:sldId xmlns:r="http://schemas.openxmlformats.org/officeDocument/2006/relationships" id="259" r:id="R6ed29fb15f274625"/>
+    <p:sldId xmlns:r="http://schemas.openxmlformats.org/officeDocument/2006/relationships" id="260" r:id="R8301f970b30a4a36"/>
+    <p:sldId xmlns:r="http://schemas.openxmlformats.org/officeDocument/2006/relationships" id="261" r:id="Rc8134a22bada4cd0"/>
+    <p:sldId xmlns:r="http://schemas.openxmlformats.org/officeDocument/2006/relationships" id="262" r:id="Rd1015ec3d08d47eb"/>
   </p:sldIdLst>
   <p:sldSz cx="12192000" cy="6858000"/>
   <p:notesSz cx="6858000" cy="9144000"/>
@@ -518,7 +518,7 @@
           <a:lstStyle xmlns:a="http://schemas.openxmlformats.org/drawingml/2006/main"/>
           <a:p xmlns:a="http://schemas.openxmlformats.org/drawingml/2006/main">
             <a:r>
-              <a:t>Пользователь видит свои заметки и записи, к которым получил доступ. На скриншоте настоящий React-интерфейс с демонстрационными API-ответами: Анна видит заметки Дмитрия и Ивана. Backend ограничивает доступ конкретной заметкой внутри пространства. Приглашённый может изменить заголовок и текст, но не удалить заметку и не поменять её пространство. Источник: frontend/src/pages/NotesPage.tsx и backend/apps/notes/views.py в текущей ветке.</a:t>
+              <a:t>Скриншот сделан в запущенном приложении после входа Марии Ивановой. Владелец Алексей Морозов создал пространство и поделился только заметкой «План защиты проекта». Соседний личный черновик остался закрыт: API вернул 404. Для съёмки использовались временные аккаунты, удалённые после проверки. Источник: frontend/src/pages/NotesPage.tsx и backend/apps/notes/views.py в ветке feature/d-shared-notes.</a:t>
             </a:r>
           </a:p>
         </p:txBody>
@@ -658,7 +658,7 @@
           <a:lstStyle xmlns:a="http://schemas.openxmlformats.org/drawingml/2006/main"/>
           <a:p xmlns:a="http://schemas.openxmlformats.org/drawingml/2006/main">
             <a:r>
-              <a:t>Frontend: React 19, TypeScript, Vite, React Router, TanStack Query и Axios. Вкладка «Общие заметки» запрашивает scope=shared. Владелец вводит email зарегистрированного пользователя в редакторе и может отозвать доступ. Приглашённый видит автора и редактирует заголовок и текст. Скриншот сделан с работающего React-интерфейса и демонстрационного API-ответа. Источники: frontend/src/pages/NotesPage.tsx, NoteEditorPage.tsx и frontend/src/api/notes.ts в текущей ветке.</a:t>
+              <a:t>Frontend: React 19, TypeScript, Vite, React Router, TanStack Query и Axios. Вкладка «Общие заметки» запрашивает scope=shared. Владелец вводит email зарегистрированного пользователя в редакторе и может отозвать доступ. На скриншоте реальная заметка, созданная временным аккаунтом Алексея и открытая Марии. Временные аккаунты удалены после съёмки. Источники: frontend/src/pages/NotesPage.tsx, NoteEditorPage.tsx и frontend/src/api/notes.ts в ветке feature/d-shared-notes.</a:t>
             </a:r>
           </a:p>
         </p:txBody>
@@ -868,7 +868,7 @@
           <a:lstStyle xmlns:a="http://schemas.openxmlformats.org/drawingml/2006/main"/>
           <a:p xmlns:a="http://schemas.openxmlformats.org/drawingml/2006/main">
             <a:r>
-              <a:t>Демонстрация с двумя зарегистрированными пользователями. Первый создаёт пространство и заметку, вводит email второго и выдаёт доступ. Второй открывает вкладку «Общие заметки», находит запись и меняет её текст. Затем первый отзывает доступ, после чего второй получает 404. Если заметку убрать из пространства, доступ также удаляется. Источник: backend/apps/notes/tests/test_business.py и frontend/src/pages в текущей ветке.</a:t>
+              <a:t>Проверенный сценарий: Алексей создаёт пространство и заметку, затем выдаёт Марии доступ по email. Мария видит запись во вкладке общих заметок и сохраняет новый текст. Снимок сделан после успешного PATCH-запроса к настоящему backend. Личный черновик Алексея не открывается у Марии и возвращает 404. Временные аккаунты и записи удалены после съёмки. Источник: backend/apps/notes/views.py и frontend/src/pages/NoteEditorPage.tsx в ветке feature/d-shared-notes.</a:t>
             </a:r>
           </a:p>
         </p:txBody>
@@ -936,7 +936,7 @@
   </p:cSld>
   <p:clrMap bg1="lt1" tx1="dk1" bg2="lt2" tx2="dk2" accent1="accent1" accent2="accent2" accent3="accent3" accent4="accent4" accent5="accent5" accent6="accent6" hlink="hlink" folHlink="folHlink"/>
   <p:sldLayoutIdLst>
-    <p:sldLayoutId xmlns:r="http://schemas.openxmlformats.org/officeDocument/2006/relationships" id="2147483649" r:id="R041652f301cc4e1a"/>
+    <p:sldLayoutId xmlns:r="http://schemas.openxmlformats.org/officeDocument/2006/relationships" id="2147483649" r:id="R7ec6a4e892604492"/>
   </p:sldLayoutIdLst>
   <p:txStyles>
     <p:titleStyle>
@@ -1665,7 +1665,7 @@
           <p:cNvPr id="5" name="">
             <a:extLst xmlns:a="http://schemas.openxmlformats.org/drawingml/2006/main">
               <a:ext uri="{FF2B5EF4-FFF2-40B4-BE49-F238E27FC236}">
-                <a16:creationId xmlns:a16="http://schemas.microsoft.com/office/drawing/2014/main" id="{35A84B01-D90E-4004-98B0-536C1A1B533F}"/>
+                <a16:creationId xmlns:a16="http://schemas.microsoft.com/office/drawing/2014/main" id="{C0ECD788-D409-448C-8ADC-F236B82F3004}"/>
               </a:ext>
             </a:extLst>
           </p:cNvPr>
@@ -1722,7 +1722,7 @@
           <p:cNvPr id="2" name="">
             <a:extLst xmlns:a="http://schemas.openxmlformats.org/drawingml/2006/main">
               <a:ext uri="{FF2B5EF4-FFF2-40B4-BE49-F238E27FC236}">
-                <a16:creationId xmlns:a16="http://schemas.microsoft.com/office/drawing/2014/main" id="{B7A0BACD-73F7-4EA6-AC67-501A57F82701}"/>
+                <a16:creationId xmlns:a16="http://schemas.microsoft.com/office/drawing/2014/main" id="{B8A9D5BE-1F99-4A7F-A171-CE25DA2F9855}"/>
               </a:ext>
             </a:extLst>
           </p:cNvPr>
@@ -1779,7 +1779,7 @@
           <p:cNvPr id="3" name="">
             <a:extLst xmlns:a="http://schemas.openxmlformats.org/drawingml/2006/main">
               <a:ext uri="{FF2B5EF4-FFF2-40B4-BE49-F238E27FC236}">
-                <a16:creationId xmlns:a16="http://schemas.microsoft.com/office/drawing/2014/main" id="{AF3A1838-0D53-49CF-96DF-2DD525F021EE}"/>
+                <a16:creationId xmlns:a16="http://schemas.microsoft.com/office/drawing/2014/main" id="{36926CD4-5C0C-44AE-91E0-771C5C5DDEA9}"/>
               </a:ext>
             </a:extLst>
           </p:cNvPr>
@@ -1836,7 +1836,7 @@
           <p:cNvPr id="4" name="">
             <a:extLst xmlns:a="http://schemas.openxmlformats.org/drawingml/2006/main">
               <a:ext uri="{FF2B5EF4-FFF2-40B4-BE49-F238E27FC236}">
-                <a16:creationId xmlns:a16="http://schemas.microsoft.com/office/drawing/2014/main" id="{BD6D91A7-95A0-48EE-95F9-677417362CF0}"/>
+                <a16:creationId xmlns:a16="http://schemas.microsoft.com/office/drawing/2014/main" id="{7C197AFD-BC1C-4F68-8C70-92749FD0A0B6}"/>
               </a:ext>
             </a:extLst>
           </p:cNvPr>
@@ -1914,7 +1914,7 @@
     </p:spTree>
     <p:extLst>
       <p:ext uri="{BB962C8B-B14F-4D97-AF65-F5344CB8AC3E}">
-        <p14:creationId xmlns:p14="http://schemas.microsoft.com/office/powerpoint/2010/main" val="663617098"/>
+        <p14:creationId xmlns:p14="http://schemas.microsoft.com/office/powerpoint/2010/main" val="2046720547"/>
       </p:ext>
     </p:extLst>
   </p:cSld>
@@ -1945,7 +1945,7 @@
           <p:cNvPr id="13" name="">
             <a:extLst xmlns:a="http://schemas.openxmlformats.org/drawingml/2006/main">
               <a:ext uri="{FF2B5EF4-FFF2-40B4-BE49-F238E27FC236}">
-                <a16:creationId xmlns:a16="http://schemas.microsoft.com/office/drawing/2014/main" id="{60B2886F-9119-4C2C-86BB-C37AE713F5FA}"/>
+                <a16:creationId xmlns:a16="http://schemas.microsoft.com/office/drawing/2014/main" id="{6F229D6F-FE4C-4961-9C47-F5995178D7B1}"/>
               </a:ext>
             </a:extLst>
           </p:cNvPr>
@@ -2002,7 +2002,7 @@
           <p:cNvPr id="2" name="">
             <a:extLst xmlns:a="http://schemas.openxmlformats.org/drawingml/2006/main">
               <a:ext uri="{FF2B5EF4-FFF2-40B4-BE49-F238E27FC236}">
-                <a16:creationId xmlns:a16="http://schemas.microsoft.com/office/drawing/2014/main" id="{723A435E-142D-4C08-826B-3C6A46C33258}"/>
+                <a16:creationId xmlns:a16="http://schemas.microsoft.com/office/drawing/2014/main" id="{941143E5-BACB-4C26-828B-050DA23A0F35}"/>
               </a:ext>
             </a:extLst>
           </p:cNvPr>
@@ -2059,7 +2059,7 @@
           <p:cNvPr id="3" name="">
             <a:extLst xmlns:a="http://schemas.openxmlformats.org/drawingml/2006/main">
               <a:ext uri="{FF2B5EF4-FFF2-40B4-BE49-F238E27FC236}">
-                <a16:creationId xmlns:a16="http://schemas.microsoft.com/office/drawing/2014/main" id="{2C8C04F5-912E-4B17-8C48-AB45D951936D}"/>
+                <a16:creationId xmlns:a16="http://schemas.microsoft.com/office/drawing/2014/main" id="{63869920-6416-4428-B50D-2573A2A14646}"/>
               </a:ext>
             </a:extLst>
           </p:cNvPr>
@@ -2116,7 +2116,7 @@
           <p:cNvPr id="4" name="">
             <a:extLst xmlns:a="http://schemas.openxmlformats.org/drawingml/2006/main">
               <a:ext uri="{FF2B5EF4-FFF2-40B4-BE49-F238E27FC236}">
-                <a16:creationId xmlns:a16="http://schemas.microsoft.com/office/drawing/2014/main" id="{D1771F3F-EDD0-4995-A948-372E15520D63}"/>
+                <a16:creationId xmlns:a16="http://schemas.microsoft.com/office/drawing/2014/main" id="{D01BEB71-5670-4A5E-8014-0CC8417C4059}"/>
               </a:ext>
             </a:extLst>
           </p:cNvPr>
@@ -2173,7 +2173,7 @@
           <p:cNvPr id="5" name="">
             <a:extLst xmlns:a="http://schemas.openxmlformats.org/drawingml/2006/main">
               <a:ext uri="{FF2B5EF4-FFF2-40B4-BE49-F238E27FC236}">
-                <a16:creationId xmlns:a16="http://schemas.microsoft.com/office/drawing/2014/main" id="{2E98FC33-6BF3-4EFD-9539-3768995EDD6B}"/>
+                <a16:creationId xmlns:a16="http://schemas.microsoft.com/office/drawing/2014/main" id="{01DAAC57-A8C8-4B5C-8EBF-66D15E5967B6}"/>
               </a:ext>
             </a:extLst>
           </p:cNvPr>
@@ -2230,7 +2230,7 @@
           <p:cNvPr id="6" name="">
             <a:extLst xmlns:a="http://schemas.openxmlformats.org/drawingml/2006/main">
               <a:ext uri="{FF2B5EF4-FFF2-40B4-BE49-F238E27FC236}">
-                <a16:creationId xmlns:a16="http://schemas.microsoft.com/office/drawing/2014/main" id="{77B09830-D9C2-4598-8F6D-85F67B3974B4}"/>
+                <a16:creationId xmlns:a16="http://schemas.microsoft.com/office/drawing/2014/main" id="{81F647E3-A42B-4300-B367-E5CCCFB16956}"/>
               </a:ext>
             </a:extLst>
           </p:cNvPr>
@@ -2287,7 +2287,7 @@
           <p:cNvPr id="7" name="">
             <a:extLst xmlns:a="http://schemas.openxmlformats.org/drawingml/2006/main">
               <a:ext uri="{FF2B5EF4-FFF2-40B4-BE49-F238E27FC236}">
-                <a16:creationId xmlns:a16="http://schemas.microsoft.com/office/drawing/2014/main" id="{866BA5FE-5B57-4294-80AA-3B1B9144F8C5}"/>
+                <a16:creationId xmlns:a16="http://schemas.microsoft.com/office/drawing/2014/main" id="{A5A5F385-5220-411D-ABD4-9A1E5AADB1E9}"/>
               </a:ext>
             </a:extLst>
           </p:cNvPr>
@@ -2344,7 +2344,7 @@
           <p:cNvPr id="8" name="">
             <a:extLst xmlns:a="http://schemas.openxmlformats.org/drawingml/2006/main">
               <a:ext uri="{FF2B5EF4-FFF2-40B4-BE49-F238E27FC236}">
-                <a16:creationId xmlns:a16="http://schemas.microsoft.com/office/drawing/2014/main" id="{93FA91C4-1DAC-4416-BB54-31C0068532D2}"/>
+                <a16:creationId xmlns:a16="http://schemas.microsoft.com/office/drawing/2014/main" id="{31B150DE-E9A7-4FE9-B725-2208C5DDF3F5}"/>
               </a:ext>
             </a:extLst>
           </p:cNvPr>
@@ -2401,7 +2401,7 @@
           <p:cNvPr id="9" name="">
             <a:extLst xmlns:a="http://schemas.openxmlformats.org/drawingml/2006/main">
               <a:ext uri="{FF2B5EF4-FFF2-40B4-BE49-F238E27FC236}">
-                <a16:creationId xmlns:a16="http://schemas.microsoft.com/office/drawing/2014/main" id="{A0C0CEE2-AAF5-490E-B6B2-8488220EA7F2}"/>
+                <a16:creationId xmlns:a16="http://schemas.microsoft.com/office/drawing/2014/main" id="{FF0B04B8-EF89-4BD8-B323-9C26C43F4E90}"/>
               </a:ext>
             </a:extLst>
           </p:cNvPr>
@@ -2458,7 +2458,7 @@
           <p:cNvPr id="10" name="">
             <a:extLst xmlns:a="http://schemas.openxmlformats.org/drawingml/2006/main">
               <a:ext uri="{FF2B5EF4-FFF2-40B4-BE49-F238E27FC236}">
-                <a16:creationId xmlns:a16="http://schemas.microsoft.com/office/drawing/2014/main" id="{F66426F6-8637-491A-BC55-6E47DE402BD3}"/>
+                <a16:creationId xmlns:a16="http://schemas.microsoft.com/office/drawing/2014/main" id="{0F066C1E-058F-4E04-B6DD-F71D878135E7}"/>
               </a:ext>
             </a:extLst>
           </p:cNvPr>
@@ -2519,13 +2519,13 @@
           <p:nvPr/>
         </p:nvPicPr>
         <p:blipFill>
-          <a:blip xmlns:r="http://schemas.openxmlformats.org/officeDocument/2006/relationships" xmlns:a="http://schemas.openxmlformats.org/drawingml/2006/main" r:embed="R89088aa690914bfb"/>
+          <a:blip xmlns:r="http://schemas.openxmlformats.org/officeDocument/2006/relationships" xmlns:a="http://schemas.openxmlformats.org/drawingml/2006/main" r:embed="Rccee1888825c42b3"/>
           <a:stretch xmlns:a="http://schemas.openxmlformats.org/drawingml/2006/main"/>
         </p:blipFill>
         <p:spPr>
           <a:xfrm xmlns:a="http://schemas.openxmlformats.org/drawingml/2006/main">
-            <a:off x="4638675" y="1524000"/>
-            <a:ext cx="6934200" cy="4333875"/>
+            <a:off x="4815240" y="1524000"/>
+            <a:ext cx="6581069" cy="4333875"/>
           </a:xfrm>
           <a:prstGeom xmlns:a="http://schemas.openxmlformats.org/drawingml/2006/main" prst="rect">
             <a:avLst/>
@@ -2537,7 +2537,7 @@
           <p:cNvPr id="12" name="">
             <a:extLst xmlns:a="http://schemas.openxmlformats.org/drawingml/2006/main">
               <a:ext uri="{FF2B5EF4-FFF2-40B4-BE49-F238E27FC236}">
-                <a16:creationId xmlns:a16="http://schemas.microsoft.com/office/drawing/2014/main" id="{F5DE595F-40D4-445E-9CFF-7293D3E0361E}"/>
+                <a16:creationId xmlns:a16="http://schemas.microsoft.com/office/drawing/2014/main" id="{1669F224-483A-4D2D-8F2A-716B58D3E1EC}"/>
               </a:ext>
             </a:extLst>
           </p:cNvPr>
@@ -2584,7 +2584,7 @@
                 <a:ea typeface="Arial"/>
                 <a:cs typeface="Arial"/>
               </a:rPr>
-              <a:t>Интерфейс с демонстрационными данными</a:t>
+              <a:t>Список заметок приглашённого пользователя</a:t>
             </a:r>
           </a:p>
         </p:txBody>
@@ -2592,7 +2592,7 @@
     </p:spTree>
     <p:extLst>
       <p:ext uri="{BB962C8B-B14F-4D97-AF65-F5344CB8AC3E}">
-        <p14:creationId xmlns:p14="http://schemas.microsoft.com/office/powerpoint/2010/main" val="1576594420"/>
+        <p14:creationId xmlns:p14="http://schemas.microsoft.com/office/powerpoint/2010/main" val="1511405187"/>
       </p:ext>
     </p:extLst>
   </p:cSld>
@@ -2623,7 +2623,7 @@
           <p:cNvPr id="15" name="">
             <a:extLst xmlns:a="http://schemas.openxmlformats.org/drawingml/2006/main">
               <a:ext uri="{FF2B5EF4-FFF2-40B4-BE49-F238E27FC236}">
-                <a16:creationId xmlns:a16="http://schemas.microsoft.com/office/drawing/2014/main" id="{E8C1D45B-CC96-45CB-B4BE-17E49CB0AFB2}"/>
+                <a16:creationId xmlns:a16="http://schemas.microsoft.com/office/drawing/2014/main" id="{C86B71CB-76A8-402C-8F65-914049C95D33}"/>
               </a:ext>
             </a:extLst>
           </p:cNvPr>
@@ -2680,7 +2680,7 @@
           <p:cNvPr id="2" name="">
             <a:extLst xmlns:a="http://schemas.openxmlformats.org/drawingml/2006/main">
               <a:ext uri="{FF2B5EF4-FFF2-40B4-BE49-F238E27FC236}">
-                <a16:creationId xmlns:a16="http://schemas.microsoft.com/office/drawing/2014/main" id="{DF534C80-0CE7-468E-B9F7-DEDD352E63EC}"/>
+                <a16:creationId xmlns:a16="http://schemas.microsoft.com/office/drawing/2014/main" id="{4512591A-153C-4254-861E-C553D4F92AE1}"/>
               </a:ext>
             </a:extLst>
           </p:cNvPr>
@@ -2737,7 +2737,7 @@
           <p:cNvPr id="3" name="">
             <a:extLst xmlns:a="http://schemas.openxmlformats.org/drawingml/2006/main">
               <a:ext uri="{FF2B5EF4-FFF2-40B4-BE49-F238E27FC236}">
-                <a16:creationId xmlns:a16="http://schemas.microsoft.com/office/drawing/2014/main" id="{57426030-7518-4075-BFA6-FAA3C1653787}"/>
+                <a16:creationId xmlns:a16="http://schemas.microsoft.com/office/drawing/2014/main" id="{BEE2AF95-65DC-465E-B4FC-666CFA3BAFB9}"/>
               </a:ext>
             </a:extLst>
           </p:cNvPr>
@@ -2794,7 +2794,7 @@
           <p:cNvPr id="4" name="">
             <a:extLst xmlns:a="http://schemas.openxmlformats.org/drawingml/2006/main">
               <a:ext uri="{FF2B5EF4-FFF2-40B4-BE49-F238E27FC236}">
-                <a16:creationId xmlns:a16="http://schemas.microsoft.com/office/drawing/2014/main" id="{80930684-A9F9-4C4B-8DCC-4176C75CBDA8}"/>
+                <a16:creationId xmlns:a16="http://schemas.microsoft.com/office/drawing/2014/main" id="{696EC423-2BDF-492D-A59B-898417911E7D}"/>
               </a:ext>
             </a:extLst>
           </p:cNvPr>
@@ -2851,7 +2851,7 @@
           <p:cNvPr id="5" name="">
             <a:extLst xmlns:a="http://schemas.openxmlformats.org/drawingml/2006/main">
               <a:ext uri="{FF2B5EF4-FFF2-40B4-BE49-F238E27FC236}">
-                <a16:creationId xmlns:a16="http://schemas.microsoft.com/office/drawing/2014/main" id="{7E34FDBF-7387-4A27-85D6-44A340ECB050}"/>
+                <a16:creationId xmlns:a16="http://schemas.microsoft.com/office/drawing/2014/main" id="{A9F51B42-889E-43D4-8D47-2A1805A7B2AE}"/>
               </a:ext>
             </a:extLst>
           </p:cNvPr>
@@ -2908,7 +2908,7 @@
           <p:cNvPr id="6" name="">
             <a:extLst xmlns:a="http://schemas.openxmlformats.org/drawingml/2006/main">
               <a:ext uri="{FF2B5EF4-FFF2-40B4-BE49-F238E27FC236}">
-                <a16:creationId xmlns:a16="http://schemas.microsoft.com/office/drawing/2014/main" id="{9F2E7B23-2A01-4E16-81AA-79DB06A25139}"/>
+                <a16:creationId xmlns:a16="http://schemas.microsoft.com/office/drawing/2014/main" id="{D8F933BB-7893-4A68-92D5-121759DB7ACC}"/>
               </a:ext>
             </a:extLst>
           </p:cNvPr>
@@ -2965,7 +2965,7 @@
           <p:cNvPr id="7" name="">
             <a:extLst xmlns:a="http://schemas.openxmlformats.org/drawingml/2006/main">
               <a:ext uri="{FF2B5EF4-FFF2-40B4-BE49-F238E27FC236}">
-                <a16:creationId xmlns:a16="http://schemas.microsoft.com/office/drawing/2014/main" id="{E2C04FBC-8773-43A3-A969-46382090E0C1}"/>
+                <a16:creationId xmlns:a16="http://schemas.microsoft.com/office/drawing/2014/main" id="{5E476224-EAAF-4675-AAF9-4DD8B3176433}"/>
               </a:ext>
             </a:extLst>
           </p:cNvPr>
@@ -3022,7 +3022,7 @@
           <p:cNvPr id="8" name="">
             <a:extLst xmlns:a="http://schemas.openxmlformats.org/drawingml/2006/main">
               <a:ext uri="{FF2B5EF4-FFF2-40B4-BE49-F238E27FC236}">
-                <a16:creationId xmlns:a16="http://schemas.microsoft.com/office/drawing/2014/main" id="{1EF219BC-FAD6-4C80-A4C8-0BD158D9645F}"/>
+                <a16:creationId xmlns:a16="http://schemas.microsoft.com/office/drawing/2014/main" id="{880A147E-17FD-49B7-9CA8-330A78814711}"/>
               </a:ext>
             </a:extLst>
           </p:cNvPr>
@@ -3079,7 +3079,7 @@
           <p:cNvPr id="9" name="">
             <a:extLst xmlns:a="http://schemas.openxmlformats.org/drawingml/2006/main">
               <a:ext uri="{FF2B5EF4-FFF2-40B4-BE49-F238E27FC236}">
-                <a16:creationId xmlns:a16="http://schemas.microsoft.com/office/drawing/2014/main" id="{0208F4EF-D154-4E2C-8314-314C2B98A650}"/>
+                <a16:creationId xmlns:a16="http://schemas.microsoft.com/office/drawing/2014/main" id="{9030D5F1-9BB5-4341-AA4A-63624324761D}"/>
               </a:ext>
             </a:extLst>
           </p:cNvPr>
@@ -3136,7 +3136,7 @@
           <p:cNvPr id="10" name="">
             <a:extLst xmlns:a="http://schemas.openxmlformats.org/drawingml/2006/main">
               <a:ext uri="{FF2B5EF4-FFF2-40B4-BE49-F238E27FC236}">
-                <a16:creationId xmlns:a16="http://schemas.microsoft.com/office/drawing/2014/main" id="{5667BF03-BEE5-4835-8187-20ADD3885230}"/>
+                <a16:creationId xmlns:a16="http://schemas.microsoft.com/office/drawing/2014/main" id="{2438EF48-51AE-4A60-BACB-5FA939A03BE0}"/>
               </a:ext>
             </a:extLst>
           </p:cNvPr>
@@ -3193,7 +3193,7 @@
           <p:cNvPr id="11" name="">
             <a:extLst xmlns:a="http://schemas.openxmlformats.org/drawingml/2006/main">
               <a:ext uri="{FF2B5EF4-FFF2-40B4-BE49-F238E27FC236}">
-                <a16:creationId xmlns:a16="http://schemas.microsoft.com/office/drawing/2014/main" id="{D63FABB5-3CD3-4557-80C7-34C596D3ED52}"/>
+                <a16:creationId xmlns:a16="http://schemas.microsoft.com/office/drawing/2014/main" id="{E4925063-133A-4403-AD27-BABC07FE2BAE}"/>
               </a:ext>
             </a:extLst>
           </p:cNvPr>
@@ -3250,7 +3250,7 @@
           <p:cNvPr id="12" name="">
             <a:extLst xmlns:a="http://schemas.openxmlformats.org/drawingml/2006/main">
               <a:ext uri="{FF2B5EF4-FFF2-40B4-BE49-F238E27FC236}">
-                <a16:creationId xmlns:a16="http://schemas.microsoft.com/office/drawing/2014/main" id="{FF7BB8A3-6FE0-4AE1-B096-B7698FED5B41}"/>
+                <a16:creationId xmlns:a16="http://schemas.microsoft.com/office/drawing/2014/main" id="{C0A81C6B-133B-4E55-A9DE-1B1332EF5A8E}"/>
               </a:ext>
             </a:extLst>
           </p:cNvPr>
@@ -3307,7 +3307,7 @@
           <p:cNvPr id="13" name="">
             <a:extLst xmlns:a="http://schemas.openxmlformats.org/drawingml/2006/main">
               <a:ext uri="{FF2B5EF4-FFF2-40B4-BE49-F238E27FC236}">
-                <a16:creationId xmlns:a16="http://schemas.microsoft.com/office/drawing/2014/main" id="{6D4F2B59-1975-4B9D-93CD-E31305E876CB}"/>
+                <a16:creationId xmlns:a16="http://schemas.microsoft.com/office/drawing/2014/main" id="{CB649BF8-5209-4380-B93D-3ED23240759D}"/>
               </a:ext>
             </a:extLst>
           </p:cNvPr>
@@ -3364,7 +3364,7 @@
           <p:cNvPr id="14" name="">
             <a:extLst xmlns:a="http://schemas.openxmlformats.org/drawingml/2006/main">
               <a:ext uri="{FF2B5EF4-FFF2-40B4-BE49-F238E27FC236}">
-                <a16:creationId xmlns:a16="http://schemas.microsoft.com/office/drawing/2014/main" id="{DA3E81E5-8218-4DB1-BE59-A2192BCBE0A3}"/>
+                <a16:creationId xmlns:a16="http://schemas.microsoft.com/office/drawing/2014/main" id="{58DBA738-9ACE-4688-BB2E-A4FC00B04310}"/>
               </a:ext>
             </a:extLst>
           </p:cNvPr>
@@ -3465,7 +3465,7 @@
     </p:spTree>
     <p:extLst>
       <p:ext uri="{BB962C8B-B14F-4D97-AF65-F5344CB8AC3E}">
-        <p14:creationId xmlns:p14="http://schemas.microsoft.com/office/powerpoint/2010/main" val="821007252"/>
+        <p14:creationId xmlns:p14="http://schemas.microsoft.com/office/powerpoint/2010/main" val="1110681539"/>
       </p:ext>
     </p:extLst>
   </p:cSld>
@@ -3496,7 +3496,7 @@
           <p:cNvPr id="14" name="">
             <a:extLst xmlns:a="http://schemas.openxmlformats.org/drawingml/2006/main">
               <a:ext uri="{FF2B5EF4-FFF2-40B4-BE49-F238E27FC236}">
-                <a16:creationId xmlns:a16="http://schemas.microsoft.com/office/drawing/2014/main" id="{3718AEF6-D1A2-474C-AEBD-7EB0F1923F89}"/>
+                <a16:creationId xmlns:a16="http://schemas.microsoft.com/office/drawing/2014/main" id="{A94DB6EB-FD0E-42D5-B4ED-13F5BE42C10D}"/>
               </a:ext>
             </a:extLst>
           </p:cNvPr>
@@ -3553,7 +3553,7 @@
           <p:cNvPr id="2" name="">
             <a:extLst xmlns:a="http://schemas.openxmlformats.org/drawingml/2006/main">
               <a:ext uri="{FF2B5EF4-FFF2-40B4-BE49-F238E27FC236}">
-                <a16:creationId xmlns:a16="http://schemas.microsoft.com/office/drawing/2014/main" id="{535E6922-2550-4EEB-9938-BF4A4CBADE51}"/>
+                <a16:creationId xmlns:a16="http://schemas.microsoft.com/office/drawing/2014/main" id="{7B2F6BDC-E616-4E12-85CF-E53EE3A2788D}"/>
               </a:ext>
             </a:extLst>
           </p:cNvPr>
@@ -3610,7 +3610,7 @@
           <p:cNvPr id="3" name="">
             <a:extLst xmlns:a="http://schemas.openxmlformats.org/drawingml/2006/main">
               <a:ext uri="{FF2B5EF4-FFF2-40B4-BE49-F238E27FC236}">
-                <a16:creationId xmlns:a16="http://schemas.microsoft.com/office/drawing/2014/main" id="{8AB1ED2D-FE13-42D6-A538-2662A5BC2B04}"/>
+                <a16:creationId xmlns:a16="http://schemas.microsoft.com/office/drawing/2014/main" id="{4E3EF6F3-6926-4D8A-A898-E0876AC213A3}"/>
               </a:ext>
             </a:extLst>
           </p:cNvPr>
@@ -3667,7 +3667,7 @@
           <p:cNvPr id="4" name="">
             <a:extLst xmlns:a="http://schemas.openxmlformats.org/drawingml/2006/main">
               <a:ext uri="{FF2B5EF4-FFF2-40B4-BE49-F238E27FC236}">
-                <a16:creationId xmlns:a16="http://schemas.microsoft.com/office/drawing/2014/main" id="{10452F44-BE3A-46A4-843F-AD8CFD80C3DA}"/>
+                <a16:creationId xmlns:a16="http://schemas.microsoft.com/office/drawing/2014/main" id="{DDA1E4AC-A537-4AF2-B0FD-BF4D659DF18D}"/>
               </a:ext>
             </a:extLst>
           </p:cNvPr>
@@ -3724,7 +3724,7 @@
           <p:cNvPr id="5" name="">
             <a:extLst xmlns:a="http://schemas.openxmlformats.org/drawingml/2006/main">
               <a:ext uri="{FF2B5EF4-FFF2-40B4-BE49-F238E27FC236}">
-                <a16:creationId xmlns:a16="http://schemas.microsoft.com/office/drawing/2014/main" id="{B4638BA8-E18D-46FB-99FE-9810EDD6D9EA}"/>
+                <a16:creationId xmlns:a16="http://schemas.microsoft.com/office/drawing/2014/main" id="{34C93466-C41E-410E-B2EB-B286547C63E9}"/>
               </a:ext>
             </a:extLst>
           </p:cNvPr>
@@ -3781,7 +3781,7 @@
           <p:cNvPr id="6" name="">
             <a:extLst xmlns:a="http://schemas.openxmlformats.org/drawingml/2006/main">
               <a:ext uri="{FF2B5EF4-FFF2-40B4-BE49-F238E27FC236}">
-                <a16:creationId xmlns:a16="http://schemas.microsoft.com/office/drawing/2014/main" id="{8C6A989B-DEF5-4338-9A5D-BAC160738CFD}"/>
+                <a16:creationId xmlns:a16="http://schemas.microsoft.com/office/drawing/2014/main" id="{2047F8A6-86D4-41FA-A9E6-FDE257F1E097}"/>
               </a:ext>
             </a:extLst>
           </p:cNvPr>
@@ -3838,7 +3838,7 @@
           <p:cNvPr id="7" name="">
             <a:extLst xmlns:a="http://schemas.openxmlformats.org/drawingml/2006/main">
               <a:ext uri="{FF2B5EF4-FFF2-40B4-BE49-F238E27FC236}">
-                <a16:creationId xmlns:a16="http://schemas.microsoft.com/office/drawing/2014/main" id="{840F579A-B9AF-47AF-B556-3720C29E2580}"/>
+                <a16:creationId xmlns:a16="http://schemas.microsoft.com/office/drawing/2014/main" id="{9F124F90-F1B1-4935-AD56-712BE5C8AD2A}"/>
               </a:ext>
             </a:extLst>
           </p:cNvPr>
@@ -3895,7 +3895,7 @@
           <p:cNvPr id="8" name="">
             <a:extLst xmlns:a="http://schemas.openxmlformats.org/drawingml/2006/main">
               <a:ext uri="{FF2B5EF4-FFF2-40B4-BE49-F238E27FC236}">
-                <a16:creationId xmlns:a16="http://schemas.microsoft.com/office/drawing/2014/main" id="{E0A10843-19AF-4995-A870-B51FEE58ABB1}"/>
+                <a16:creationId xmlns:a16="http://schemas.microsoft.com/office/drawing/2014/main" id="{2313010D-FD69-4F3E-84FF-C54AFE408C9E}"/>
               </a:ext>
             </a:extLst>
           </p:cNvPr>
@@ -3952,7 +3952,7 @@
           <p:cNvPr id="9" name="">
             <a:extLst xmlns:a="http://schemas.openxmlformats.org/drawingml/2006/main">
               <a:ext uri="{FF2B5EF4-FFF2-40B4-BE49-F238E27FC236}">
-                <a16:creationId xmlns:a16="http://schemas.microsoft.com/office/drawing/2014/main" id="{CF385EC5-89A8-4E0E-83E9-2D169B218D69}"/>
+                <a16:creationId xmlns:a16="http://schemas.microsoft.com/office/drawing/2014/main" id="{7B8EB1B1-0639-48DF-9A1B-6323E3BC8066}"/>
               </a:ext>
             </a:extLst>
           </p:cNvPr>
@@ -4009,7 +4009,7 @@
           <p:cNvPr id="10" name="">
             <a:extLst xmlns:a="http://schemas.openxmlformats.org/drawingml/2006/main">
               <a:ext uri="{FF2B5EF4-FFF2-40B4-BE49-F238E27FC236}">
-                <a16:creationId xmlns:a16="http://schemas.microsoft.com/office/drawing/2014/main" id="{FC693629-013B-43D1-8912-88E9E8224F9C}"/>
+                <a16:creationId xmlns:a16="http://schemas.microsoft.com/office/drawing/2014/main" id="{E0BC3D6A-F33E-4FB2-AF9D-8690783BA286}"/>
               </a:ext>
             </a:extLst>
           </p:cNvPr>
@@ -4066,7 +4066,7 @@
           <p:cNvPr id="11" name="">
             <a:extLst xmlns:a="http://schemas.openxmlformats.org/drawingml/2006/main">
               <a:ext uri="{FF2B5EF4-FFF2-40B4-BE49-F238E27FC236}">
-                <a16:creationId xmlns:a16="http://schemas.microsoft.com/office/drawing/2014/main" id="{E0AE83CB-4103-4801-A9D4-7889EB4817F3}"/>
+                <a16:creationId xmlns:a16="http://schemas.microsoft.com/office/drawing/2014/main" id="{8654E17C-F58E-4CC9-BEEB-FFA4F161008A}"/>
               </a:ext>
             </a:extLst>
           </p:cNvPr>
@@ -4127,13 +4127,13 @@
           <p:nvPr/>
         </p:nvPicPr>
         <p:blipFill>
-          <a:blip xmlns:r="http://schemas.openxmlformats.org/officeDocument/2006/relationships" xmlns:a="http://schemas.openxmlformats.org/drawingml/2006/main" r:embed="Re12d7e1eac5d4854"/>
+          <a:blip xmlns:r="http://schemas.openxmlformats.org/officeDocument/2006/relationships" xmlns:a="http://schemas.openxmlformats.org/drawingml/2006/main" r:embed="Rf3a810d3f12a4a52"/>
           <a:stretch xmlns:a="http://schemas.openxmlformats.org/drawingml/2006/main"/>
         </p:blipFill>
         <p:spPr>
           <a:xfrm xmlns:a="http://schemas.openxmlformats.org/drawingml/2006/main">
-            <a:off x="4895850" y="2589404"/>
-            <a:ext cx="6686550" cy="2222116"/>
+            <a:off x="4895850" y="2911954"/>
+            <a:ext cx="6686550" cy="1577017"/>
           </a:xfrm>
           <a:prstGeom xmlns:a="http://schemas.openxmlformats.org/drawingml/2006/main" prst="rect">
             <a:avLst/>
@@ -4145,7 +4145,7 @@
           <p:cNvPr id="13" name="">
             <a:extLst xmlns:a="http://schemas.openxmlformats.org/drawingml/2006/main">
               <a:ext uri="{FF2B5EF4-FFF2-40B4-BE49-F238E27FC236}">
-                <a16:creationId xmlns:a16="http://schemas.microsoft.com/office/drawing/2014/main" id="{47B139C6-7A3A-46EA-BCBD-D7BDB568FD09}"/>
+                <a16:creationId xmlns:a16="http://schemas.microsoft.com/office/drawing/2014/main" id="{9C48C0E9-B9E5-4647-B56B-41720069C734}"/>
               </a:ext>
             </a:extLst>
           </p:cNvPr>
@@ -4200,7 +4200,7 @@
     </p:spTree>
     <p:extLst>
       <p:ext uri="{BB962C8B-B14F-4D97-AF65-F5344CB8AC3E}">
-        <p14:creationId xmlns:p14="http://schemas.microsoft.com/office/powerpoint/2010/main" val="803327877"/>
+        <p14:creationId xmlns:p14="http://schemas.microsoft.com/office/powerpoint/2010/main" val="516122125"/>
       </p:ext>
     </p:extLst>
   </p:cSld>
@@ -4231,7 +4231,7 @@
           <p:cNvPr id="9" name="">
             <a:extLst xmlns:a="http://schemas.openxmlformats.org/drawingml/2006/main">
               <a:ext uri="{FF2B5EF4-FFF2-40B4-BE49-F238E27FC236}">
-                <a16:creationId xmlns:a16="http://schemas.microsoft.com/office/drawing/2014/main" id="{D563C234-96D3-4EB3-A078-C465B8DE6869}"/>
+                <a16:creationId xmlns:a16="http://schemas.microsoft.com/office/drawing/2014/main" id="{728BC722-DD42-42D8-9683-58414F48B8E0}"/>
               </a:ext>
             </a:extLst>
           </p:cNvPr>
@@ -4288,7 +4288,7 @@
           <p:cNvPr id="2" name="">
             <a:extLst xmlns:a="http://schemas.openxmlformats.org/drawingml/2006/main">
               <a:ext uri="{FF2B5EF4-FFF2-40B4-BE49-F238E27FC236}">
-                <a16:creationId xmlns:a16="http://schemas.microsoft.com/office/drawing/2014/main" id="{ED7F92B8-6152-4427-ACCA-44A08468B998}"/>
+                <a16:creationId xmlns:a16="http://schemas.microsoft.com/office/drawing/2014/main" id="{BDF4EE97-FAEE-42C4-AA94-3E8C7F7F0C3E}"/>
               </a:ext>
             </a:extLst>
           </p:cNvPr>
@@ -4352,7 +4352,7 @@
         </p:xfrm>
         <a:graphic xmlns:a="http://schemas.openxmlformats.org/drawingml/2006/main">
           <a:graphicData uri="http://schemas.openxmlformats.org/drawingml/2006/chart">
-            <c:chart xmlns:r="http://schemas.openxmlformats.org/officeDocument/2006/relationships" xmlns:c="http://schemas.openxmlformats.org/drawingml/2006/chart" r:id="Rc0e82ce1beb14132"/>
+            <c:chart xmlns:r="http://schemas.openxmlformats.org/officeDocument/2006/relationships" xmlns:c="http://schemas.openxmlformats.org/drawingml/2006/chart" r:id="Re777846aa6284ed5"/>
           </a:graphicData>
         </a:graphic>
       </p:graphicFrame>
@@ -4361,7 +4361,7 @@
           <p:cNvPr id="4" name="">
             <a:extLst xmlns:a="http://schemas.openxmlformats.org/drawingml/2006/main">
               <a:ext uri="{FF2B5EF4-FFF2-40B4-BE49-F238E27FC236}">
-                <a16:creationId xmlns:a16="http://schemas.microsoft.com/office/drawing/2014/main" id="{E87E786D-0764-480B-B13F-062F0ADA9305}"/>
+                <a16:creationId xmlns:a16="http://schemas.microsoft.com/office/drawing/2014/main" id="{73772678-275B-4875-A75E-8523A89B2E88}"/>
               </a:ext>
             </a:extLst>
           </p:cNvPr>
@@ -4418,7 +4418,7 @@
           <p:cNvPr id="5" name="">
             <a:extLst xmlns:a="http://schemas.openxmlformats.org/drawingml/2006/main">
               <a:ext uri="{FF2B5EF4-FFF2-40B4-BE49-F238E27FC236}">
-                <a16:creationId xmlns:a16="http://schemas.microsoft.com/office/drawing/2014/main" id="{7F3E8143-4E62-462F-B434-F49CF370426D}"/>
+                <a16:creationId xmlns:a16="http://schemas.microsoft.com/office/drawing/2014/main" id="{34196D70-F448-4AFF-B296-CDBA39063A56}"/>
               </a:ext>
             </a:extLst>
           </p:cNvPr>
@@ -4475,7 +4475,7 @@
           <p:cNvPr id="6" name="">
             <a:extLst xmlns:a="http://schemas.openxmlformats.org/drawingml/2006/main">
               <a:ext uri="{FF2B5EF4-FFF2-40B4-BE49-F238E27FC236}">
-                <a16:creationId xmlns:a16="http://schemas.microsoft.com/office/drawing/2014/main" id="{F56E3B2C-121A-401C-8CCF-704C496C3082}"/>
+                <a16:creationId xmlns:a16="http://schemas.microsoft.com/office/drawing/2014/main" id="{C24C7FDE-4CAC-436B-9B93-94954BE7C089}"/>
               </a:ext>
             </a:extLst>
           </p:cNvPr>
@@ -4532,7 +4532,7 @@
           <p:cNvPr id="7" name="">
             <a:extLst xmlns:a="http://schemas.openxmlformats.org/drawingml/2006/main">
               <a:ext uri="{FF2B5EF4-FFF2-40B4-BE49-F238E27FC236}">
-                <a16:creationId xmlns:a16="http://schemas.microsoft.com/office/drawing/2014/main" id="{ED7274D5-33AA-409C-87F1-196011644844}"/>
+                <a16:creationId xmlns:a16="http://schemas.microsoft.com/office/drawing/2014/main" id="{57557D5E-5D98-4274-A5AD-BD2AF143F39C}"/>
               </a:ext>
             </a:extLst>
           </p:cNvPr>
@@ -4589,7 +4589,7 @@
           <p:cNvPr id="8" name="">
             <a:extLst xmlns:a="http://schemas.openxmlformats.org/drawingml/2006/main">
               <a:ext uri="{FF2B5EF4-FFF2-40B4-BE49-F238E27FC236}">
-                <a16:creationId xmlns:a16="http://schemas.microsoft.com/office/drawing/2014/main" id="{CEE0D26E-9365-498D-AC8B-E322E0C0B14A}"/>
+                <a16:creationId xmlns:a16="http://schemas.microsoft.com/office/drawing/2014/main" id="{15E18953-A6B5-4CF4-B77F-2786794CFB3F}"/>
               </a:ext>
             </a:extLst>
           </p:cNvPr>
@@ -4644,7 +4644,7 @@
     </p:spTree>
     <p:extLst>
       <p:ext uri="{BB962C8B-B14F-4D97-AF65-F5344CB8AC3E}">
-        <p14:creationId xmlns:p14="http://schemas.microsoft.com/office/powerpoint/2010/main" val="452769547"/>
+        <p14:creationId xmlns:p14="http://schemas.microsoft.com/office/powerpoint/2010/main" val="934596310"/>
       </p:ext>
     </p:extLst>
   </p:cSld>
@@ -4675,7 +4675,7 @@
           <p:cNvPr id="18" name="">
             <a:extLst xmlns:a="http://schemas.openxmlformats.org/drawingml/2006/main">
               <a:ext uri="{FF2B5EF4-FFF2-40B4-BE49-F238E27FC236}">
-                <a16:creationId xmlns:a16="http://schemas.microsoft.com/office/drawing/2014/main" id="{27A685DD-67C6-44A0-B37C-C0CE5D67AA09}"/>
+                <a16:creationId xmlns:a16="http://schemas.microsoft.com/office/drawing/2014/main" id="{BD1AF542-D154-431C-82DB-1F1B42555292}"/>
               </a:ext>
             </a:extLst>
           </p:cNvPr>
@@ -4732,7 +4732,7 @@
           <p:cNvPr id="2" name="">
             <a:extLst xmlns:a="http://schemas.openxmlformats.org/drawingml/2006/main">
               <a:ext uri="{FF2B5EF4-FFF2-40B4-BE49-F238E27FC236}">
-                <a16:creationId xmlns:a16="http://schemas.microsoft.com/office/drawing/2014/main" id="{623D8D34-79CA-47F0-9B03-A7E015B8A05B}"/>
+                <a16:creationId xmlns:a16="http://schemas.microsoft.com/office/drawing/2014/main" id="{A23F4454-E9BF-4889-B780-832F68F4A970}"/>
               </a:ext>
             </a:extLst>
           </p:cNvPr>
@@ -4789,7 +4789,7 @@
           <p:cNvPr id="3" name="">
             <a:extLst xmlns:a="http://schemas.openxmlformats.org/drawingml/2006/main">
               <a:ext uri="{FF2B5EF4-FFF2-40B4-BE49-F238E27FC236}">
-                <a16:creationId xmlns:a16="http://schemas.microsoft.com/office/drawing/2014/main" id="{9234327C-CAE8-4A2F-B003-B088E5082C54}"/>
+                <a16:creationId xmlns:a16="http://schemas.microsoft.com/office/drawing/2014/main" id="{5363CD10-4C36-4D90-A698-181877C85C9D}"/>
               </a:ext>
             </a:extLst>
           </p:cNvPr>
@@ -4846,7 +4846,7 @@
           <p:cNvPr id="4" name="">
             <a:extLst xmlns:a="http://schemas.openxmlformats.org/drawingml/2006/main">
               <a:ext uri="{FF2B5EF4-FFF2-40B4-BE49-F238E27FC236}">
-                <a16:creationId xmlns:a16="http://schemas.microsoft.com/office/drawing/2014/main" id="{4D09215B-4333-4524-84BD-DBEE67960196}"/>
+                <a16:creationId xmlns:a16="http://schemas.microsoft.com/office/drawing/2014/main" id="{43029713-B466-4274-9284-D66ED29B4C67}"/>
               </a:ext>
             </a:extLst>
           </p:cNvPr>
@@ -4903,7 +4903,7 @@
           <p:cNvPr id="5" name="">
             <a:extLst xmlns:a="http://schemas.openxmlformats.org/drawingml/2006/main">
               <a:ext uri="{FF2B5EF4-FFF2-40B4-BE49-F238E27FC236}">
-                <a16:creationId xmlns:a16="http://schemas.microsoft.com/office/drawing/2014/main" id="{BED2EB16-0685-4BFB-A57C-82DC9BC0496E}"/>
+                <a16:creationId xmlns:a16="http://schemas.microsoft.com/office/drawing/2014/main" id="{55EEEC29-1896-48C8-B20A-3B5A55AB97C3}"/>
               </a:ext>
             </a:extLst>
           </p:cNvPr>
@@ -4960,7 +4960,7 @@
           <p:cNvPr id="6" name="">
             <a:extLst xmlns:a="http://schemas.openxmlformats.org/drawingml/2006/main">
               <a:ext uri="{FF2B5EF4-FFF2-40B4-BE49-F238E27FC236}">
-                <a16:creationId xmlns:a16="http://schemas.microsoft.com/office/drawing/2014/main" id="{468D1F30-575B-4197-82C1-A617829DBE59}"/>
+                <a16:creationId xmlns:a16="http://schemas.microsoft.com/office/drawing/2014/main" id="{6987EAFB-D945-454B-8DDA-8DEDF24D080A}"/>
               </a:ext>
             </a:extLst>
           </p:cNvPr>
@@ -5017,7 +5017,7 @@
           <p:cNvPr id="7" name="">
             <a:extLst xmlns:a="http://schemas.openxmlformats.org/drawingml/2006/main">
               <a:ext uri="{FF2B5EF4-FFF2-40B4-BE49-F238E27FC236}">
-                <a16:creationId xmlns:a16="http://schemas.microsoft.com/office/drawing/2014/main" id="{11693C4D-81F9-4E36-8147-2DEFE67B98EB}"/>
+                <a16:creationId xmlns:a16="http://schemas.microsoft.com/office/drawing/2014/main" id="{3D4C5548-EA48-47F4-83BC-A470C579D903}"/>
               </a:ext>
             </a:extLst>
           </p:cNvPr>
@@ -5074,7 +5074,7 @@
           <p:cNvPr id="8" name="">
             <a:extLst xmlns:a="http://schemas.openxmlformats.org/drawingml/2006/main">
               <a:ext uri="{FF2B5EF4-FFF2-40B4-BE49-F238E27FC236}">
-                <a16:creationId xmlns:a16="http://schemas.microsoft.com/office/drawing/2014/main" id="{453E817F-6B3E-4118-B2B7-4DC9B1158A7F}"/>
+                <a16:creationId xmlns:a16="http://schemas.microsoft.com/office/drawing/2014/main" id="{1F12CF59-DBD6-4F6E-9D01-229F844FA73C}"/>
               </a:ext>
             </a:extLst>
           </p:cNvPr>
@@ -5131,7 +5131,7 @@
           <p:cNvPr id="9" name="">
             <a:extLst xmlns:a="http://schemas.openxmlformats.org/drawingml/2006/main">
               <a:ext uri="{FF2B5EF4-FFF2-40B4-BE49-F238E27FC236}">
-                <a16:creationId xmlns:a16="http://schemas.microsoft.com/office/drawing/2014/main" id="{77E5BC01-A821-47AB-B8D9-AC119FA53F5C}"/>
+                <a16:creationId xmlns:a16="http://schemas.microsoft.com/office/drawing/2014/main" id="{C7CAC800-5140-46FB-9840-5AC4A4DC419A}"/>
               </a:ext>
             </a:extLst>
           </p:cNvPr>
@@ -5188,7 +5188,7 @@
           <p:cNvPr id="10" name="">
             <a:extLst xmlns:a="http://schemas.openxmlformats.org/drawingml/2006/main">
               <a:ext uri="{FF2B5EF4-FFF2-40B4-BE49-F238E27FC236}">
-                <a16:creationId xmlns:a16="http://schemas.microsoft.com/office/drawing/2014/main" id="{64557F2A-BD1E-4302-AC46-37F8ABE87735}"/>
+                <a16:creationId xmlns:a16="http://schemas.microsoft.com/office/drawing/2014/main" id="{AA6DD803-F1AA-4F33-8125-F3F9FB85C309}"/>
               </a:ext>
             </a:extLst>
           </p:cNvPr>
@@ -5245,7 +5245,7 @@
           <p:cNvPr id="11" name="">
             <a:extLst xmlns:a="http://schemas.openxmlformats.org/drawingml/2006/main">
               <a:ext uri="{FF2B5EF4-FFF2-40B4-BE49-F238E27FC236}">
-                <a16:creationId xmlns:a16="http://schemas.microsoft.com/office/drawing/2014/main" id="{05F407A6-FE5A-41F2-B00E-FF04423CA81E}"/>
+                <a16:creationId xmlns:a16="http://schemas.microsoft.com/office/drawing/2014/main" id="{AC6558DB-306F-4E49-969F-2D840552C59A}"/>
               </a:ext>
             </a:extLst>
           </p:cNvPr>
@@ -5302,7 +5302,7 @@
           <p:cNvPr id="12" name="">
             <a:extLst xmlns:a="http://schemas.openxmlformats.org/drawingml/2006/main">
               <a:ext uri="{FF2B5EF4-FFF2-40B4-BE49-F238E27FC236}">
-                <a16:creationId xmlns:a16="http://schemas.microsoft.com/office/drawing/2014/main" id="{C098D71D-1912-4414-9AF7-AE05A3EFAC30}"/>
+                <a16:creationId xmlns:a16="http://schemas.microsoft.com/office/drawing/2014/main" id="{C014147E-0EC0-41AF-8C8A-0823C317D924}"/>
               </a:ext>
             </a:extLst>
           </p:cNvPr>
@@ -5359,7 +5359,7 @@
           <p:cNvPr id="13" name="">
             <a:extLst xmlns:a="http://schemas.openxmlformats.org/drawingml/2006/main">
               <a:ext uri="{FF2B5EF4-FFF2-40B4-BE49-F238E27FC236}">
-                <a16:creationId xmlns:a16="http://schemas.microsoft.com/office/drawing/2014/main" id="{BB7A5E0C-7F09-4B52-AEAA-95E37316793F}"/>
+                <a16:creationId xmlns:a16="http://schemas.microsoft.com/office/drawing/2014/main" id="{BC422FB4-7FDB-4171-959C-E03EB596617D}"/>
               </a:ext>
             </a:extLst>
           </p:cNvPr>
@@ -5416,7 +5416,7 @@
           <p:cNvPr id="14" name="">
             <a:extLst xmlns:a="http://schemas.openxmlformats.org/drawingml/2006/main">
               <a:ext uri="{FF2B5EF4-FFF2-40B4-BE49-F238E27FC236}">
-                <a16:creationId xmlns:a16="http://schemas.microsoft.com/office/drawing/2014/main" id="{29BCCED2-7731-4A60-AC3C-E3607855F86D}"/>
+                <a16:creationId xmlns:a16="http://schemas.microsoft.com/office/drawing/2014/main" id="{9740F03D-0AB3-4A0A-85BB-9E320F8551F0}"/>
               </a:ext>
             </a:extLst>
           </p:cNvPr>
@@ -5473,7 +5473,7 @@
           <p:cNvPr id="15" name="">
             <a:extLst xmlns:a="http://schemas.openxmlformats.org/drawingml/2006/main">
               <a:ext uri="{FF2B5EF4-FFF2-40B4-BE49-F238E27FC236}">
-                <a16:creationId xmlns:a16="http://schemas.microsoft.com/office/drawing/2014/main" id="{52B4BF84-580B-473D-B62B-0EE32C75A482}"/>
+                <a16:creationId xmlns:a16="http://schemas.microsoft.com/office/drawing/2014/main" id="{96917F50-D8EB-40D4-AD1D-5197A90C2F7D}"/>
               </a:ext>
             </a:extLst>
           </p:cNvPr>
@@ -5530,7 +5530,7 @@
           <p:cNvPr id="16" name="">
             <a:extLst xmlns:a="http://schemas.openxmlformats.org/drawingml/2006/main">
               <a:ext uri="{FF2B5EF4-FFF2-40B4-BE49-F238E27FC236}">
-                <a16:creationId xmlns:a16="http://schemas.microsoft.com/office/drawing/2014/main" id="{DD8F6196-12DC-4AC3-BCA6-B2309D58A8B9}"/>
+                <a16:creationId xmlns:a16="http://schemas.microsoft.com/office/drawing/2014/main" id="{FA27A2FA-269C-4094-854C-03FE58940F1F}"/>
               </a:ext>
             </a:extLst>
           </p:cNvPr>
@@ -5587,7 +5587,7 @@
           <p:cNvPr id="17" name="">
             <a:extLst xmlns:a="http://schemas.openxmlformats.org/drawingml/2006/main">
               <a:ext uri="{FF2B5EF4-FFF2-40B4-BE49-F238E27FC236}">
-                <a16:creationId xmlns:a16="http://schemas.microsoft.com/office/drawing/2014/main" id="{DCB47B9B-DE2C-4041-9E6C-AD925549839B}"/>
+                <a16:creationId xmlns:a16="http://schemas.microsoft.com/office/drawing/2014/main" id="{4EF60227-E068-48C2-92F5-013C289DBB15}"/>
               </a:ext>
             </a:extLst>
           </p:cNvPr>
@@ -5642,7 +5642,7 @@
     </p:spTree>
     <p:extLst>
       <p:ext uri="{BB962C8B-B14F-4D97-AF65-F5344CB8AC3E}">
-        <p14:creationId xmlns:p14="http://schemas.microsoft.com/office/powerpoint/2010/main" val="2089218194"/>
+        <p14:creationId xmlns:p14="http://schemas.microsoft.com/office/powerpoint/2010/main" val="1271489732"/>
       </p:ext>
     </p:extLst>
   </p:cSld>
@@ -5670,10 +5670,10 @@
       </p:grpSpPr>
       <p:sp>
         <p:nvSpPr>
-          <p:cNvPr id="12" name="">
-            <a:extLst xmlns:a="http://schemas.openxmlformats.org/drawingml/2006/main">
-              <a:ext uri="{FF2B5EF4-FFF2-40B4-BE49-F238E27FC236}">
-                <a16:creationId xmlns:a16="http://schemas.microsoft.com/office/drawing/2014/main" id="{B68B4A11-A029-4C07-BC2A-781AFADDA850}"/>
+          <p:cNvPr id="11" name="">
+            <a:extLst xmlns:a="http://schemas.openxmlformats.org/drawingml/2006/main">
+              <a:ext uri="{FF2B5EF4-FFF2-40B4-BE49-F238E27FC236}">
+                <a16:creationId xmlns:a16="http://schemas.microsoft.com/office/drawing/2014/main" id="{DAE3806D-6E97-4C8B-AB26-5DDAF6A2CA91}"/>
               </a:ext>
             </a:extLst>
           </p:cNvPr>
@@ -5730,7 +5730,7 @@
           <p:cNvPr id="2" name="">
             <a:extLst xmlns:a="http://schemas.openxmlformats.org/drawingml/2006/main">
               <a:ext uri="{FF2B5EF4-FFF2-40B4-BE49-F238E27FC236}">
-                <a16:creationId xmlns:a16="http://schemas.microsoft.com/office/drawing/2014/main" id="{5B159DB4-585F-4D1C-8889-884DE4CE4480}"/>
+                <a16:creationId xmlns:a16="http://schemas.microsoft.com/office/drawing/2014/main" id="{113B6518-7B48-4D9E-A1EC-656BDF709193}"/>
               </a:ext>
             </a:extLst>
           </p:cNvPr>
@@ -5787,46 +5787,46 @@
           <p:cNvPr id="3" name="">
             <a:extLst xmlns:a="http://schemas.openxmlformats.org/drawingml/2006/main">
               <a:ext uri="{FF2B5EF4-FFF2-40B4-BE49-F238E27FC236}">
-                <a16:creationId xmlns:a16="http://schemas.microsoft.com/office/drawing/2014/main" id="{664A7A62-1965-4C6F-8E12-3A53D1BE8248}"/>
-              </a:ext>
-            </a:extLst>
-          </p:cNvPr>
-          <p:cNvSpPr>
-            <a:spLocks xmlns:a="http://schemas.openxmlformats.org/drawingml/2006/main" noGrp="1"/>
-          </p:cNvSpPr>
-          <p:nvPr/>
-        </p:nvSpPr>
-        <p:spPr>
-          <a:xfrm xmlns:a="http://schemas.openxmlformats.org/drawingml/2006/main">
-            <a:off x="628650" y="1676400"/>
-            <a:ext cx="828675" cy="600075"/>
-          </a:xfrm>
-          <a:prstGeom xmlns:a="http://schemas.openxmlformats.org/drawingml/2006/main" prst="rect">
-            <a:avLst/>
-          </a:prstGeom>
-          <a:noFill xmlns:a="http://schemas.openxmlformats.org/drawingml/2006/main"/>
-          <a:ln xmlns:a="http://schemas.openxmlformats.org/drawingml/2006/main" w="0">
-            <a:noFill/>
-          </a:ln>
-        </p:spPr>
-        <p:txBody>
-          <a:bodyPr xmlns:a="http://schemas.openxmlformats.org/drawingml/2006/main">
-            <a:noAutofit/>
-          </a:bodyPr>
-          <a:lstStyle xmlns:a="http://schemas.openxmlformats.org/drawingml/2006/main"/>
-          <a:p xmlns:a="http://schemas.openxmlformats.org/drawingml/2006/main">
-            <a:pPr>
-              <a:defRPr sz="3150" b="1">
-                <a:solidFill>
-                  <a:srgbClr val="171717"/>
-                </a:solidFill>
-                <a:latin typeface="Arial"/>
-                <a:ea typeface="Arial"/>
-                <a:cs typeface="Arial"/>
-              </a:defRPr>
-            </a:pPr>
-            <a:r>
-              <a:rPr sz="3150" b="1">
+                <a16:creationId xmlns:a16="http://schemas.microsoft.com/office/drawing/2014/main" id="{DB96F94F-F799-4951-B305-37E6A5DD72FF}"/>
+              </a:ext>
+            </a:extLst>
+          </p:cNvPr>
+          <p:cNvSpPr>
+            <a:spLocks xmlns:a="http://schemas.openxmlformats.org/drawingml/2006/main" noGrp="1"/>
+          </p:cNvSpPr>
+          <p:nvPr/>
+        </p:nvSpPr>
+        <p:spPr>
+          <a:xfrm xmlns:a="http://schemas.openxmlformats.org/drawingml/2006/main">
+            <a:off x="628650" y="1752600"/>
+            <a:ext cx="714375" cy="552450"/>
+          </a:xfrm>
+          <a:prstGeom xmlns:a="http://schemas.openxmlformats.org/drawingml/2006/main" prst="rect">
+            <a:avLst/>
+          </a:prstGeom>
+          <a:noFill xmlns:a="http://schemas.openxmlformats.org/drawingml/2006/main"/>
+          <a:ln xmlns:a="http://schemas.openxmlformats.org/drawingml/2006/main" w="0">
+            <a:noFill/>
+          </a:ln>
+        </p:spPr>
+        <p:txBody>
+          <a:bodyPr xmlns:a="http://schemas.openxmlformats.org/drawingml/2006/main">
+            <a:noAutofit/>
+          </a:bodyPr>
+          <a:lstStyle xmlns:a="http://schemas.openxmlformats.org/drawingml/2006/main"/>
+          <a:p xmlns:a="http://schemas.openxmlformats.org/drawingml/2006/main">
+            <a:pPr>
+              <a:defRPr sz="2925" b="1">
+                <a:solidFill>
+                  <a:srgbClr val="171717"/>
+                </a:solidFill>
+                <a:latin typeface="Arial"/>
+                <a:ea typeface="Arial"/>
+                <a:cs typeface="Arial"/>
+              </a:defRPr>
+            </a:pPr>
+            <a:r>
+              <a:rPr sz="2925" b="1">
                 <a:solidFill>
                   <a:srgbClr val="171717"/>
                 </a:solidFill>
@@ -5844,54 +5844,54 @@
           <p:cNvPr id="4" name="">
             <a:extLst xmlns:a="http://schemas.openxmlformats.org/drawingml/2006/main">
               <a:ext uri="{FF2B5EF4-FFF2-40B4-BE49-F238E27FC236}">
-                <a16:creationId xmlns:a16="http://schemas.microsoft.com/office/drawing/2014/main" id="{0B0892C1-FD0E-4D3C-8B8A-C2AEEB0B0928}"/>
-              </a:ext>
-            </a:extLst>
-          </p:cNvPr>
-          <p:cNvSpPr>
-            <a:spLocks xmlns:a="http://schemas.openxmlformats.org/drawingml/2006/main" noGrp="1"/>
-          </p:cNvSpPr>
-          <p:nvPr/>
-        </p:nvSpPr>
-        <p:spPr>
-          <a:xfrm xmlns:a="http://schemas.openxmlformats.org/drawingml/2006/main">
-            <a:off x="1781175" y="1771650"/>
-            <a:ext cx="9620250" cy="600075"/>
-          </a:xfrm>
-          <a:prstGeom xmlns:a="http://schemas.openxmlformats.org/drawingml/2006/main" prst="rect">
-            <a:avLst/>
-          </a:prstGeom>
-          <a:noFill xmlns:a="http://schemas.openxmlformats.org/drawingml/2006/main"/>
-          <a:ln xmlns:a="http://schemas.openxmlformats.org/drawingml/2006/main" w="0">
-            <a:noFill/>
-          </a:ln>
-        </p:spPr>
-        <p:txBody>
-          <a:bodyPr xmlns:a="http://schemas.openxmlformats.org/drawingml/2006/main">
-            <a:noAutofit/>
-          </a:bodyPr>
-          <a:lstStyle xmlns:a="http://schemas.openxmlformats.org/drawingml/2006/main"/>
-          <a:p xmlns:a="http://schemas.openxmlformats.org/drawingml/2006/main">
-            <a:pPr>
-              <a:defRPr sz="2400" b="0">
-                <a:solidFill>
-                  <a:srgbClr val="171717"/>
-                </a:solidFill>
-                <a:latin typeface="Arial"/>
-                <a:ea typeface="Arial"/>
-                <a:cs typeface="Arial"/>
-              </a:defRPr>
-            </a:pPr>
-            <a:r>
-              <a:rPr sz="2400" b="0">
-                <a:solidFill>
-                  <a:srgbClr val="171717"/>
-                </a:solidFill>
-                <a:latin typeface="Arial"/>
-                <a:ea typeface="Arial"/>
-                <a:cs typeface="Arial"/>
-              </a:rPr>
-              <a:t>Войти под первым пользователем</a:t>
+                <a16:creationId xmlns:a16="http://schemas.microsoft.com/office/drawing/2014/main" id="{50D33442-5191-411B-AD71-9F2F86949396}"/>
+              </a:ext>
+            </a:extLst>
+          </p:cNvPr>
+          <p:cNvSpPr>
+            <a:spLocks xmlns:a="http://schemas.openxmlformats.org/drawingml/2006/main" noGrp="1"/>
+          </p:cNvSpPr>
+          <p:nvPr/>
+        </p:nvSpPr>
+        <p:spPr>
+          <a:xfrm xmlns:a="http://schemas.openxmlformats.org/drawingml/2006/main">
+            <a:off x="1476375" y="1809750"/>
+            <a:ext cx="3333750" cy="838200"/>
+          </a:xfrm>
+          <a:prstGeom xmlns:a="http://schemas.openxmlformats.org/drawingml/2006/main" prst="rect">
+            <a:avLst/>
+          </a:prstGeom>
+          <a:noFill xmlns:a="http://schemas.openxmlformats.org/drawingml/2006/main"/>
+          <a:ln xmlns:a="http://schemas.openxmlformats.org/drawingml/2006/main" w="0">
+            <a:noFill/>
+          </a:ln>
+        </p:spPr>
+        <p:txBody>
+          <a:bodyPr xmlns:a="http://schemas.openxmlformats.org/drawingml/2006/main">
+            <a:noAutofit/>
+          </a:bodyPr>
+          <a:lstStyle xmlns:a="http://schemas.openxmlformats.org/drawingml/2006/main"/>
+          <a:p xmlns:a="http://schemas.openxmlformats.org/drawingml/2006/main">
+            <a:pPr>
+              <a:defRPr sz="2025" b="0">
+                <a:solidFill>
+                  <a:srgbClr val="171717"/>
+                </a:solidFill>
+                <a:latin typeface="Arial"/>
+                <a:ea typeface="Arial"/>
+                <a:cs typeface="Arial"/>
+              </a:defRPr>
+            </a:pPr>
+            <a:r>
+              <a:rPr sz="2025" b="0">
+                <a:solidFill>
+                  <a:srgbClr val="171717"/>
+                </a:solidFill>
+                <a:latin typeface="Arial"/>
+                <a:ea typeface="Arial"/>
+                <a:cs typeface="Arial"/>
+              </a:rPr>
+              <a:t>Создать пространство и заметку</a:t>
             </a:r>
           </a:p>
         </p:txBody>
@@ -5901,46 +5901,46 @@
           <p:cNvPr id="5" name="">
             <a:extLst xmlns:a="http://schemas.openxmlformats.org/drawingml/2006/main">
               <a:ext uri="{FF2B5EF4-FFF2-40B4-BE49-F238E27FC236}">
-                <a16:creationId xmlns:a16="http://schemas.microsoft.com/office/drawing/2014/main" id="{1E11F0F3-6CBA-4278-A7DC-92DC4C40D2C5}"/>
-              </a:ext>
-            </a:extLst>
-          </p:cNvPr>
-          <p:cNvSpPr>
-            <a:spLocks xmlns:a="http://schemas.openxmlformats.org/drawingml/2006/main" noGrp="1"/>
-          </p:cNvSpPr>
-          <p:nvPr/>
-        </p:nvSpPr>
-        <p:spPr>
-          <a:xfrm xmlns:a="http://schemas.openxmlformats.org/drawingml/2006/main">
-            <a:off x="628650" y="2667000"/>
-            <a:ext cx="828675" cy="600075"/>
-          </a:xfrm>
-          <a:prstGeom xmlns:a="http://schemas.openxmlformats.org/drawingml/2006/main" prst="rect">
-            <a:avLst/>
-          </a:prstGeom>
-          <a:noFill xmlns:a="http://schemas.openxmlformats.org/drawingml/2006/main"/>
-          <a:ln xmlns:a="http://schemas.openxmlformats.org/drawingml/2006/main" w="0">
-            <a:noFill/>
-          </a:ln>
-        </p:spPr>
-        <p:txBody>
-          <a:bodyPr xmlns:a="http://schemas.openxmlformats.org/drawingml/2006/main">
-            <a:noAutofit/>
-          </a:bodyPr>
-          <a:lstStyle xmlns:a="http://schemas.openxmlformats.org/drawingml/2006/main"/>
-          <a:p xmlns:a="http://schemas.openxmlformats.org/drawingml/2006/main">
-            <a:pPr>
-              <a:defRPr sz="3150" b="1">
-                <a:solidFill>
-                  <a:srgbClr val="171717"/>
-                </a:solidFill>
-                <a:latin typeface="Arial"/>
-                <a:ea typeface="Arial"/>
-                <a:cs typeface="Arial"/>
-              </a:defRPr>
-            </a:pPr>
-            <a:r>
-              <a:rPr sz="3150" b="1">
+                <a16:creationId xmlns:a16="http://schemas.microsoft.com/office/drawing/2014/main" id="{8F04A8CE-5FE2-41F0-92C0-4AB8253DD312}"/>
+              </a:ext>
+            </a:extLst>
+          </p:cNvPr>
+          <p:cNvSpPr>
+            <a:spLocks xmlns:a="http://schemas.openxmlformats.org/drawingml/2006/main" noGrp="1"/>
+          </p:cNvSpPr>
+          <p:nvPr/>
+        </p:nvSpPr>
+        <p:spPr>
+          <a:xfrm xmlns:a="http://schemas.openxmlformats.org/drawingml/2006/main">
+            <a:off x="628650" y="2990850"/>
+            <a:ext cx="714375" cy="552450"/>
+          </a:xfrm>
+          <a:prstGeom xmlns:a="http://schemas.openxmlformats.org/drawingml/2006/main" prst="rect">
+            <a:avLst/>
+          </a:prstGeom>
+          <a:noFill xmlns:a="http://schemas.openxmlformats.org/drawingml/2006/main"/>
+          <a:ln xmlns:a="http://schemas.openxmlformats.org/drawingml/2006/main" w="0">
+            <a:noFill/>
+          </a:ln>
+        </p:spPr>
+        <p:txBody>
+          <a:bodyPr xmlns:a="http://schemas.openxmlformats.org/drawingml/2006/main">
+            <a:noAutofit/>
+          </a:bodyPr>
+          <a:lstStyle xmlns:a="http://schemas.openxmlformats.org/drawingml/2006/main"/>
+          <a:p xmlns:a="http://schemas.openxmlformats.org/drawingml/2006/main">
+            <a:pPr>
+              <a:defRPr sz="2925" b="1">
+                <a:solidFill>
+                  <a:srgbClr val="171717"/>
+                </a:solidFill>
+                <a:latin typeface="Arial"/>
+                <a:ea typeface="Arial"/>
+                <a:cs typeface="Arial"/>
+              </a:defRPr>
+            </a:pPr>
+            <a:r>
+              <a:rPr sz="2925" b="1">
                 <a:solidFill>
                   <a:srgbClr val="171717"/>
                 </a:solidFill>
@@ -5958,54 +5958,54 @@
           <p:cNvPr id="6" name="">
             <a:extLst xmlns:a="http://schemas.openxmlformats.org/drawingml/2006/main">
               <a:ext uri="{FF2B5EF4-FFF2-40B4-BE49-F238E27FC236}">
-                <a16:creationId xmlns:a16="http://schemas.microsoft.com/office/drawing/2014/main" id="{8C2E08F7-C672-42DA-8D60-A3D1E6AB50EE}"/>
-              </a:ext>
-            </a:extLst>
-          </p:cNvPr>
-          <p:cNvSpPr>
-            <a:spLocks xmlns:a="http://schemas.openxmlformats.org/drawingml/2006/main" noGrp="1"/>
-          </p:cNvSpPr>
-          <p:nvPr/>
-        </p:nvSpPr>
-        <p:spPr>
-          <a:xfrm xmlns:a="http://schemas.openxmlformats.org/drawingml/2006/main">
-            <a:off x="1781175" y="2762250"/>
-            <a:ext cx="9620250" cy="600075"/>
-          </a:xfrm>
-          <a:prstGeom xmlns:a="http://schemas.openxmlformats.org/drawingml/2006/main" prst="rect">
-            <a:avLst/>
-          </a:prstGeom>
-          <a:noFill xmlns:a="http://schemas.openxmlformats.org/drawingml/2006/main"/>
-          <a:ln xmlns:a="http://schemas.openxmlformats.org/drawingml/2006/main" w="0">
-            <a:noFill/>
-          </a:ln>
-        </p:spPr>
-        <p:txBody>
-          <a:bodyPr xmlns:a="http://schemas.openxmlformats.org/drawingml/2006/main">
-            <a:noAutofit/>
-          </a:bodyPr>
-          <a:lstStyle xmlns:a="http://schemas.openxmlformats.org/drawingml/2006/main"/>
-          <a:p xmlns:a="http://schemas.openxmlformats.org/drawingml/2006/main">
-            <a:pPr>
-              <a:defRPr sz="2400" b="0">
-                <a:solidFill>
-                  <a:srgbClr val="171717"/>
-                </a:solidFill>
-                <a:latin typeface="Arial"/>
-                <a:ea typeface="Arial"/>
-                <a:cs typeface="Arial"/>
-              </a:defRPr>
-            </a:pPr>
-            <a:r>
-              <a:rPr sz="2400" b="0">
-                <a:solidFill>
-                  <a:srgbClr val="171717"/>
-                </a:solidFill>
-                <a:latin typeface="Arial"/>
-                <a:ea typeface="Arial"/>
-                <a:cs typeface="Arial"/>
-              </a:rPr>
-              <a:t>Создать заметку и выбрать участников</a:t>
+                <a16:creationId xmlns:a16="http://schemas.microsoft.com/office/drawing/2014/main" id="{9E77B120-A1D3-4F8B-9086-1F2149F50844}"/>
+              </a:ext>
+            </a:extLst>
+          </p:cNvPr>
+          <p:cNvSpPr>
+            <a:spLocks xmlns:a="http://schemas.openxmlformats.org/drawingml/2006/main" noGrp="1"/>
+          </p:cNvSpPr>
+          <p:nvPr/>
+        </p:nvSpPr>
+        <p:spPr>
+          <a:xfrm xmlns:a="http://schemas.openxmlformats.org/drawingml/2006/main">
+            <a:off x="1476375" y="3048000"/>
+            <a:ext cx="3333750" cy="838200"/>
+          </a:xfrm>
+          <a:prstGeom xmlns:a="http://schemas.openxmlformats.org/drawingml/2006/main" prst="rect">
+            <a:avLst/>
+          </a:prstGeom>
+          <a:noFill xmlns:a="http://schemas.openxmlformats.org/drawingml/2006/main"/>
+          <a:ln xmlns:a="http://schemas.openxmlformats.org/drawingml/2006/main" w="0">
+            <a:noFill/>
+          </a:ln>
+        </p:spPr>
+        <p:txBody>
+          <a:bodyPr xmlns:a="http://schemas.openxmlformats.org/drawingml/2006/main">
+            <a:noAutofit/>
+          </a:bodyPr>
+          <a:lstStyle xmlns:a="http://schemas.openxmlformats.org/drawingml/2006/main"/>
+          <a:p xmlns:a="http://schemas.openxmlformats.org/drawingml/2006/main">
+            <a:pPr>
+              <a:defRPr sz="2025" b="0">
+                <a:solidFill>
+                  <a:srgbClr val="171717"/>
+                </a:solidFill>
+                <a:latin typeface="Arial"/>
+                <a:ea typeface="Arial"/>
+                <a:cs typeface="Arial"/>
+              </a:defRPr>
+            </a:pPr>
+            <a:r>
+              <a:rPr sz="2025" b="0">
+                <a:solidFill>
+                  <a:srgbClr val="171717"/>
+                </a:solidFill>
+                <a:latin typeface="Arial"/>
+                <a:ea typeface="Arial"/>
+                <a:cs typeface="Arial"/>
+              </a:rPr>
+              <a:t>Выдать доступ по email</a:t>
             </a:r>
           </a:p>
         </p:txBody>
@@ -6015,46 +6015,46 @@
           <p:cNvPr id="7" name="">
             <a:extLst xmlns:a="http://schemas.openxmlformats.org/drawingml/2006/main">
               <a:ext uri="{FF2B5EF4-FFF2-40B4-BE49-F238E27FC236}">
-                <a16:creationId xmlns:a16="http://schemas.microsoft.com/office/drawing/2014/main" id="{D99753B2-726A-45E5-B5B0-157D3C95023F}"/>
-              </a:ext>
-            </a:extLst>
-          </p:cNvPr>
-          <p:cNvSpPr>
-            <a:spLocks xmlns:a="http://schemas.openxmlformats.org/drawingml/2006/main" noGrp="1"/>
-          </p:cNvSpPr>
-          <p:nvPr/>
-        </p:nvSpPr>
-        <p:spPr>
-          <a:xfrm xmlns:a="http://schemas.openxmlformats.org/drawingml/2006/main">
-            <a:off x="628650" y="3657600"/>
-            <a:ext cx="828675" cy="600075"/>
-          </a:xfrm>
-          <a:prstGeom xmlns:a="http://schemas.openxmlformats.org/drawingml/2006/main" prst="rect">
-            <a:avLst/>
-          </a:prstGeom>
-          <a:noFill xmlns:a="http://schemas.openxmlformats.org/drawingml/2006/main"/>
-          <a:ln xmlns:a="http://schemas.openxmlformats.org/drawingml/2006/main" w="0">
-            <a:noFill/>
-          </a:ln>
-        </p:spPr>
-        <p:txBody>
-          <a:bodyPr xmlns:a="http://schemas.openxmlformats.org/drawingml/2006/main">
-            <a:noAutofit/>
-          </a:bodyPr>
-          <a:lstStyle xmlns:a="http://schemas.openxmlformats.org/drawingml/2006/main"/>
-          <a:p xmlns:a="http://schemas.openxmlformats.org/drawingml/2006/main">
-            <a:pPr>
-              <a:defRPr sz="3150" b="1">
-                <a:solidFill>
-                  <a:srgbClr val="171717"/>
-                </a:solidFill>
-                <a:latin typeface="Arial"/>
-                <a:ea typeface="Arial"/>
-                <a:cs typeface="Arial"/>
-              </a:defRPr>
-            </a:pPr>
-            <a:r>
-              <a:rPr sz="3150" b="1">
+                <a16:creationId xmlns:a16="http://schemas.microsoft.com/office/drawing/2014/main" id="{B786A543-393D-4211-AE5E-4498F6A8FAD6}"/>
+              </a:ext>
+            </a:extLst>
+          </p:cNvPr>
+          <p:cNvSpPr>
+            <a:spLocks xmlns:a="http://schemas.openxmlformats.org/drawingml/2006/main" noGrp="1"/>
+          </p:cNvSpPr>
+          <p:nvPr/>
+        </p:nvSpPr>
+        <p:spPr>
+          <a:xfrm xmlns:a="http://schemas.openxmlformats.org/drawingml/2006/main">
+            <a:off x="628650" y="4229100"/>
+            <a:ext cx="714375" cy="552450"/>
+          </a:xfrm>
+          <a:prstGeom xmlns:a="http://schemas.openxmlformats.org/drawingml/2006/main" prst="rect">
+            <a:avLst/>
+          </a:prstGeom>
+          <a:noFill xmlns:a="http://schemas.openxmlformats.org/drawingml/2006/main"/>
+          <a:ln xmlns:a="http://schemas.openxmlformats.org/drawingml/2006/main" w="0">
+            <a:noFill/>
+          </a:ln>
+        </p:spPr>
+        <p:txBody>
+          <a:bodyPr xmlns:a="http://schemas.openxmlformats.org/drawingml/2006/main">
+            <a:noAutofit/>
+          </a:bodyPr>
+          <a:lstStyle xmlns:a="http://schemas.openxmlformats.org/drawingml/2006/main"/>
+          <a:p xmlns:a="http://schemas.openxmlformats.org/drawingml/2006/main">
+            <a:pPr>
+              <a:defRPr sz="2925" b="1">
+                <a:solidFill>
+                  <a:srgbClr val="171717"/>
+                </a:solidFill>
+                <a:latin typeface="Arial"/>
+                <a:ea typeface="Arial"/>
+                <a:cs typeface="Arial"/>
+              </a:defRPr>
+            </a:pPr>
+            <a:r>
+              <a:rPr sz="2925" b="1">
                 <a:solidFill>
                   <a:srgbClr val="171717"/>
                 </a:solidFill>
@@ -6072,225 +6072,133 @@
           <p:cNvPr id="8" name="">
             <a:extLst xmlns:a="http://schemas.openxmlformats.org/drawingml/2006/main">
               <a:ext uri="{FF2B5EF4-FFF2-40B4-BE49-F238E27FC236}">
-                <a16:creationId xmlns:a16="http://schemas.microsoft.com/office/drawing/2014/main" id="{CFDBDD02-4473-462F-92D1-1C48B0E3533D}"/>
-              </a:ext>
-            </a:extLst>
-          </p:cNvPr>
-          <p:cNvSpPr>
-            <a:spLocks xmlns:a="http://schemas.openxmlformats.org/drawingml/2006/main" noGrp="1"/>
-          </p:cNvSpPr>
-          <p:nvPr/>
-        </p:nvSpPr>
-        <p:spPr>
-          <a:xfrm xmlns:a="http://schemas.openxmlformats.org/drawingml/2006/main">
-            <a:off x="1781175" y="3752850"/>
-            <a:ext cx="9620250" cy="600075"/>
-          </a:xfrm>
-          <a:prstGeom xmlns:a="http://schemas.openxmlformats.org/drawingml/2006/main" prst="rect">
-            <a:avLst/>
-          </a:prstGeom>
-          <a:noFill xmlns:a="http://schemas.openxmlformats.org/drawingml/2006/main"/>
-          <a:ln xmlns:a="http://schemas.openxmlformats.org/drawingml/2006/main" w="0">
-            <a:noFill/>
-          </a:ln>
-        </p:spPr>
-        <p:txBody>
-          <a:bodyPr xmlns:a="http://schemas.openxmlformats.org/drawingml/2006/main">
-            <a:noAutofit/>
-          </a:bodyPr>
-          <a:lstStyle xmlns:a="http://schemas.openxmlformats.org/drawingml/2006/main"/>
-          <a:p xmlns:a="http://schemas.openxmlformats.org/drawingml/2006/main">
-            <a:pPr>
-              <a:defRPr sz="2400" b="0">
-                <a:solidFill>
-                  <a:srgbClr val="171717"/>
-                </a:solidFill>
-                <a:latin typeface="Arial"/>
-                <a:ea typeface="Arial"/>
-                <a:cs typeface="Arial"/>
-              </a:defRPr>
-            </a:pPr>
-            <a:r>
-              <a:rPr sz="2400" b="0">
-                <a:solidFill>
-                  <a:srgbClr val="171717"/>
-                </a:solidFill>
-                <a:latin typeface="Arial"/>
-                <a:ea typeface="Arial"/>
-                <a:cs typeface="Arial"/>
-              </a:rPr>
-              <a:t>Войти под вторым пользователем</a:t>
-            </a:r>
-          </a:p>
-        </p:txBody>
-      </p:sp>
-      <p:sp>
-        <p:nvSpPr>
-          <p:cNvPr id="9" name="">
-            <a:extLst xmlns:a="http://schemas.openxmlformats.org/drawingml/2006/main">
-              <a:ext uri="{FF2B5EF4-FFF2-40B4-BE49-F238E27FC236}">
-                <a16:creationId xmlns:a16="http://schemas.microsoft.com/office/drawing/2014/main" id="{FFB5F7E3-A885-4957-90E7-2BF2BEE9FE80}"/>
-              </a:ext>
-            </a:extLst>
-          </p:cNvPr>
-          <p:cNvSpPr>
-            <a:spLocks xmlns:a="http://schemas.openxmlformats.org/drawingml/2006/main" noGrp="1"/>
-          </p:cNvSpPr>
-          <p:nvPr/>
-        </p:nvSpPr>
-        <p:spPr>
-          <a:xfrm xmlns:a="http://schemas.openxmlformats.org/drawingml/2006/main">
-            <a:off x="628650" y="4648200"/>
-            <a:ext cx="828675" cy="600075"/>
-          </a:xfrm>
-          <a:prstGeom xmlns:a="http://schemas.openxmlformats.org/drawingml/2006/main" prst="rect">
-            <a:avLst/>
-          </a:prstGeom>
-          <a:noFill xmlns:a="http://schemas.openxmlformats.org/drawingml/2006/main"/>
-          <a:ln xmlns:a="http://schemas.openxmlformats.org/drawingml/2006/main" w="0">
-            <a:noFill/>
-          </a:ln>
-        </p:spPr>
-        <p:txBody>
-          <a:bodyPr xmlns:a="http://schemas.openxmlformats.org/drawingml/2006/main">
-            <a:noAutofit/>
-          </a:bodyPr>
-          <a:lstStyle xmlns:a="http://schemas.openxmlformats.org/drawingml/2006/main"/>
-          <a:p xmlns:a="http://schemas.openxmlformats.org/drawingml/2006/main">
-            <a:pPr>
-              <a:defRPr sz="3150" b="1">
-                <a:solidFill>
-                  <a:srgbClr val="171717"/>
-                </a:solidFill>
-                <a:latin typeface="Arial"/>
-                <a:ea typeface="Arial"/>
-                <a:cs typeface="Arial"/>
-              </a:defRPr>
-            </a:pPr>
-            <a:r>
-              <a:rPr sz="3150" b="1">
-                <a:solidFill>
-                  <a:srgbClr val="171717"/>
-                </a:solidFill>
-                <a:latin typeface="Arial"/>
-                <a:ea typeface="Arial"/>
-                <a:cs typeface="Arial"/>
-              </a:rPr>
-              <a:t>04</a:t>
-            </a:r>
-          </a:p>
-        </p:txBody>
-      </p:sp>
+                <a16:creationId xmlns:a16="http://schemas.microsoft.com/office/drawing/2014/main" id="{5946F485-DDB7-4195-91DE-88851A006D14}"/>
+              </a:ext>
+            </a:extLst>
+          </p:cNvPr>
+          <p:cNvSpPr>
+            <a:spLocks xmlns:a="http://schemas.openxmlformats.org/drawingml/2006/main" noGrp="1"/>
+          </p:cNvSpPr>
+          <p:nvPr/>
+        </p:nvSpPr>
+        <p:spPr>
+          <a:xfrm xmlns:a="http://schemas.openxmlformats.org/drawingml/2006/main">
+            <a:off x="1476375" y="4286250"/>
+            <a:ext cx="3333750" cy="838200"/>
+          </a:xfrm>
+          <a:prstGeom xmlns:a="http://schemas.openxmlformats.org/drawingml/2006/main" prst="rect">
+            <a:avLst/>
+          </a:prstGeom>
+          <a:noFill xmlns:a="http://schemas.openxmlformats.org/drawingml/2006/main"/>
+          <a:ln xmlns:a="http://schemas.openxmlformats.org/drawingml/2006/main" w="0">
+            <a:noFill/>
+          </a:ln>
+        </p:spPr>
+        <p:txBody>
+          <a:bodyPr xmlns:a="http://schemas.openxmlformats.org/drawingml/2006/main">
+            <a:noAutofit/>
+          </a:bodyPr>
+          <a:lstStyle xmlns:a="http://schemas.openxmlformats.org/drawingml/2006/main"/>
+          <a:p xmlns:a="http://schemas.openxmlformats.org/drawingml/2006/main">
+            <a:pPr>
+              <a:defRPr sz="2025" b="0">
+                <a:solidFill>
+                  <a:srgbClr val="171717"/>
+                </a:solidFill>
+                <a:latin typeface="Arial"/>
+                <a:ea typeface="Arial"/>
+                <a:cs typeface="Arial"/>
+              </a:defRPr>
+            </a:pPr>
+            <a:r>
+              <a:rPr sz="2025" b="0">
+                <a:solidFill>
+                  <a:srgbClr val="171717"/>
+                </a:solidFill>
+                <a:latin typeface="Arial"/>
+                <a:ea typeface="Arial"/>
+                <a:cs typeface="Arial"/>
+              </a:rPr>
+              <a:t>Второй пользователь меняет текст</a:t>
+            </a:r>
+          </a:p>
+        </p:txBody>
+      </p:sp>
+      <p:pic>
+        <p:nvPicPr>
+          <p:cNvPr id="19" name=""/>
+          <p:cNvPicPr>
+            <a:picLocks xmlns:a="http://schemas.openxmlformats.org/drawingml/2006/main" noChangeAspect="1"/>
+          </p:cNvPicPr>
+          <p:nvPr/>
+        </p:nvPicPr>
+        <p:blipFill>
+          <a:blip xmlns:r="http://schemas.openxmlformats.org/officeDocument/2006/relationships" xmlns:a="http://schemas.openxmlformats.org/drawingml/2006/main" r:embed="R222714eca7714016"/>
+          <a:stretch xmlns:a="http://schemas.openxmlformats.org/drawingml/2006/main"/>
+        </p:blipFill>
+        <p:spPr>
+          <a:xfrm xmlns:a="http://schemas.openxmlformats.org/drawingml/2006/main">
+            <a:off x="4905375" y="2337110"/>
+            <a:ext cx="6572250" cy="2564780"/>
+          </a:xfrm>
+          <a:prstGeom xmlns:a="http://schemas.openxmlformats.org/drawingml/2006/main" prst="rect">
+            <a:avLst/>
+          </a:prstGeom>
+        </p:spPr>
+      </p:pic>
       <p:sp>
         <p:nvSpPr>
           <p:cNvPr id="10" name="">
             <a:extLst xmlns:a="http://schemas.openxmlformats.org/drawingml/2006/main">
               <a:ext uri="{FF2B5EF4-FFF2-40B4-BE49-F238E27FC236}">
-                <a16:creationId xmlns:a16="http://schemas.microsoft.com/office/drawing/2014/main" id="{C2810863-0A78-4BF8-835E-613C1022DC08}"/>
-              </a:ext>
-            </a:extLst>
-          </p:cNvPr>
-          <p:cNvSpPr>
-            <a:spLocks xmlns:a="http://schemas.openxmlformats.org/drawingml/2006/main" noGrp="1"/>
-          </p:cNvSpPr>
-          <p:nvPr/>
-        </p:nvSpPr>
-        <p:spPr>
-          <a:xfrm xmlns:a="http://schemas.openxmlformats.org/drawingml/2006/main">
-            <a:off x="1781175" y="4743450"/>
-            <a:ext cx="9620250" cy="600075"/>
-          </a:xfrm>
-          <a:prstGeom xmlns:a="http://schemas.openxmlformats.org/drawingml/2006/main" prst="rect">
-            <a:avLst/>
-          </a:prstGeom>
-          <a:noFill xmlns:a="http://schemas.openxmlformats.org/drawingml/2006/main"/>
-          <a:ln xmlns:a="http://schemas.openxmlformats.org/drawingml/2006/main" w="0">
-            <a:noFill/>
-          </a:ln>
-        </p:spPr>
-        <p:txBody>
-          <a:bodyPr xmlns:a="http://schemas.openxmlformats.org/drawingml/2006/main">
-            <a:noAutofit/>
-          </a:bodyPr>
-          <a:lstStyle xmlns:a="http://schemas.openxmlformats.org/drawingml/2006/main"/>
-          <a:p xmlns:a="http://schemas.openxmlformats.org/drawingml/2006/main">
-            <a:pPr>
-              <a:defRPr sz="2400" b="0">
-                <a:solidFill>
-                  <a:srgbClr val="171717"/>
-                </a:solidFill>
-                <a:latin typeface="Arial"/>
-                <a:ea typeface="Arial"/>
-                <a:cs typeface="Arial"/>
-              </a:defRPr>
-            </a:pPr>
-            <a:r>
-              <a:rPr sz="2400" b="0">
-                <a:solidFill>
-                  <a:srgbClr val="171717"/>
-                </a:solidFill>
-                <a:latin typeface="Arial"/>
-                <a:ea typeface="Arial"/>
-                <a:cs typeface="Arial"/>
-              </a:rPr>
-              <a:t>Открыть общую заметку и проверить права</a:t>
-            </a:r>
-          </a:p>
-        </p:txBody>
-      </p:sp>
-      <p:sp>
-        <p:nvSpPr>
-          <p:cNvPr id="11" name="">
-            <a:extLst xmlns:a="http://schemas.openxmlformats.org/drawingml/2006/main">
-              <a:ext uri="{FF2B5EF4-FFF2-40B4-BE49-F238E27FC236}">
-                <a16:creationId xmlns:a16="http://schemas.microsoft.com/office/drawing/2014/main" id="{A5E010E9-D905-445C-88EB-C10C6E6EC1BD}"/>
-              </a:ext>
-            </a:extLst>
-          </p:cNvPr>
-          <p:cNvSpPr>
-            <a:spLocks xmlns:a="http://schemas.openxmlformats.org/drawingml/2006/main" noGrp="1"/>
-          </p:cNvSpPr>
-          <p:nvPr/>
-        </p:nvSpPr>
-        <p:spPr>
-          <a:xfrm xmlns:a="http://schemas.openxmlformats.org/drawingml/2006/main">
-            <a:off x="609600" y="6115050"/>
-            <a:ext cx="10287000" cy="333375"/>
-          </a:xfrm>
-          <a:prstGeom xmlns:a="http://schemas.openxmlformats.org/drawingml/2006/main" prst="rect">
-            <a:avLst/>
-          </a:prstGeom>
-          <a:noFill xmlns:a="http://schemas.openxmlformats.org/drawingml/2006/main"/>
-          <a:ln xmlns:a="http://schemas.openxmlformats.org/drawingml/2006/main" w="0">
-            <a:noFill/>
-          </a:ln>
-        </p:spPr>
-        <p:txBody>
-          <a:bodyPr xmlns:a="http://schemas.openxmlformats.org/drawingml/2006/main">
-            <a:noAutofit/>
-          </a:bodyPr>
-          <a:lstStyle xmlns:a="http://schemas.openxmlformats.org/drawingml/2006/main"/>
-          <a:p xmlns:a="http://schemas.openxmlformats.org/drawingml/2006/main">
-            <a:pPr>
-              <a:defRPr sz="1725" b="0">
-                <a:solidFill>
-                  <a:srgbClr val="555555"/>
-                </a:solidFill>
-                <a:latin typeface="Arial"/>
-                <a:ea typeface="Arial"/>
-                <a:cs typeface="Arial"/>
-              </a:defRPr>
-            </a:pPr>
-            <a:r>
-              <a:rPr sz="1725" b="0">
-                <a:solidFill>
-                  <a:srgbClr val="555555"/>
-                </a:solidFill>
-                <a:latin typeface="Arial"/>
-                <a:ea typeface="Arial"/>
-                <a:cs typeface="Arial"/>
-              </a:rPr>
-              <a:t>github.com/NE4EL/Smart-notes</a:t>
+                <a16:creationId xmlns:a16="http://schemas.microsoft.com/office/drawing/2014/main" id="{CB36B029-8593-4159-A1D2-D239490E730A}"/>
+              </a:ext>
+            </a:extLst>
+          </p:cNvPr>
+          <p:cNvSpPr>
+            <a:spLocks xmlns:a="http://schemas.openxmlformats.org/drawingml/2006/main" noGrp="1"/>
+          </p:cNvSpPr>
+          <p:nvPr/>
+        </p:nvSpPr>
+        <p:spPr>
+          <a:xfrm xmlns:a="http://schemas.openxmlformats.org/drawingml/2006/main">
+            <a:off x="5810250" y="5334000"/>
+            <a:ext cx="5667375" cy="257175"/>
+          </a:xfrm>
+          <a:prstGeom xmlns:a="http://schemas.openxmlformats.org/drawingml/2006/main" prst="rect">
+            <a:avLst/>
+          </a:prstGeom>
+          <a:noFill xmlns:a="http://schemas.openxmlformats.org/drawingml/2006/main"/>
+          <a:ln xmlns:a="http://schemas.openxmlformats.org/drawingml/2006/main" w="0">
+            <a:noFill/>
+          </a:ln>
+        </p:spPr>
+        <p:txBody>
+          <a:bodyPr xmlns:a="http://schemas.openxmlformats.org/drawingml/2006/main">
+            <a:noAutofit/>
+          </a:bodyPr>
+          <a:lstStyle xmlns:a="http://schemas.openxmlformats.org/drawingml/2006/main"/>
+          <a:p xmlns:a="http://schemas.openxmlformats.org/drawingml/2006/main">
+            <a:pPr>
+              <a:defRPr sz="1275" b="0">
+                <a:solidFill>
+                  <a:srgbClr val="666666"/>
+                </a:solidFill>
+                <a:latin typeface="Arial"/>
+                <a:ea typeface="Arial"/>
+                <a:cs typeface="Arial"/>
+              </a:defRPr>
+            </a:pPr>
+            <a:r>
+              <a:rPr sz="1275" b="0">
+                <a:solidFill>
+                  <a:srgbClr val="666666"/>
+                </a:solidFill>
+                <a:latin typeface="Arial"/>
+                <a:ea typeface="Arial"/>
+                <a:cs typeface="Arial"/>
+              </a:rPr>
+              <a:t>Редактор приглашённого пользователя</a:t>
             </a:r>
           </a:p>
         </p:txBody>
@@ -6298,7 +6206,7 @@
     </p:spTree>
     <p:extLst>
       <p:ext uri="{BB962C8B-B14F-4D97-AF65-F5344CB8AC3E}">
-        <p14:creationId xmlns:p14="http://schemas.microsoft.com/office/powerpoint/2010/main" val="1784861207"/>
+        <p14:creationId xmlns:p14="http://schemas.microsoft.com/office/powerpoint/2010/main" val="837095066"/>
       </p:ext>
     </p:extLst>
   </p:cSld>

</xml_diff>